<commit_message>
added minor slide deck template improvement
</commit_message>
<xml_diff>
--- a/Lectures/Slides/SE-Deck-Template.pptx
+++ b/Lectures/Slides/SE-Deck-Template.pptx
@@ -5,25 +5,26 @@
     <p:sldMasterId id="2147483648" r:id="rId1"/>
   </p:sldMasterIdLst>
   <p:notesMasterIdLst>
-    <p:notesMasterId r:id="rId18"/>
+    <p:notesMasterId r:id="rId19"/>
   </p:notesMasterIdLst>
   <p:sldIdLst>
     <p:sldId id="256" r:id="rId2"/>
     <p:sldId id="257" r:id="rId3"/>
-    <p:sldId id="258" r:id="rId4"/>
-    <p:sldId id="259" r:id="rId5"/>
-    <p:sldId id="260" r:id="rId6"/>
-    <p:sldId id="261" r:id="rId7"/>
-    <p:sldId id="262" r:id="rId8"/>
-    <p:sldId id="263" r:id="rId9"/>
-    <p:sldId id="264" r:id="rId10"/>
-    <p:sldId id="265" r:id="rId11"/>
-    <p:sldId id="266" r:id="rId12"/>
-    <p:sldId id="267" r:id="rId13"/>
-    <p:sldId id="268" r:id="rId14"/>
-    <p:sldId id="269" r:id="rId15"/>
-    <p:sldId id="271" r:id="rId16"/>
-    <p:sldId id="270" r:id="rId17"/>
+    <p:sldId id="272" r:id="rId4"/>
+    <p:sldId id="258" r:id="rId5"/>
+    <p:sldId id="259" r:id="rId6"/>
+    <p:sldId id="260" r:id="rId7"/>
+    <p:sldId id="261" r:id="rId8"/>
+    <p:sldId id="262" r:id="rId9"/>
+    <p:sldId id="263" r:id="rId10"/>
+    <p:sldId id="264" r:id="rId11"/>
+    <p:sldId id="265" r:id="rId12"/>
+    <p:sldId id="266" r:id="rId13"/>
+    <p:sldId id="267" r:id="rId14"/>
+    <p:sldId id="268" r:id="rId15"/>
+    <p:sldId id="269" r:id="rId16"/>
+    <p:sldId id="271" r:id="rId17"/>
+    <p:sldId id="270" r:id="rId18"/>
   </p:sldIdLst>
   <p:sldSz cx="12192000" cy="6858000"/>
   <p:notesSz cx="6858000" cy="9144000"/>
@@ -261,7 +262,7 @@
       <p15:sldGuideLst xmlns:p15="http://schemas.microsoft.com/office/powerpoint/2012/main"/>
     </p:ext>
     <p:ext uri="http://customooxmlschemas.google.com/">
-      <go:slidesCustomData xmlns="" xmlns:mc="http://schemas.openxmlformats.org/markup-compatibility/2006" xmlns:mv="urn:schemas-microsoft-com:mac:vml" xmlns:c="http://schemas.openxmlformats.org/drawingml/2006/chart" xmlns:dgm="http://schemas.openxmlformats.org/drawingml/2006/diagram" xmlns:o="urn:schemas-microsoft-com:office:office" xmlns:v="urn:schemas-microsoft-com:vml" xmlns:pvml="urn:schemas-microsoft-com:office:powerpoint" xmlns:com="http://schemas.openxmlformats.org/drawingml/2006/compatibility" xmlns:p14="http://schemas.microsoft.com/office/powerpoint/2010/main" xmlns:p15="http://schemas.microsoft.com/office/powerpoint/2012/main" xmlns:ahyp="http://schemas.microsoft.com/office/drawing/2018/hyperlinkcolor" xmlns:go="http://customooxmlschemas.google.com/" r:id="rId20" roundtripDataSignature="AMtx7mjKkk5wOoQj6sDPPETbbKgHU96Dzg=="/>
+      <go:slidesCustomData xmlns:go="http://customooxmlschemas.google.com/" xmlns:ahyp="http://schemas.microsoft.com/office/drawing/2018/hyperlinkcolor" xmlns:p15="http://schemas.microsoft.com/office/powerpoint/2012/main" xmlns:p14="http://schemas.microsoft.com/office/powerpoint/2010/main" xmlns:com="http://schemas.openxmlformats.org/drawingml/2006/compatibility" xmlns:pvml="urn:schemas-microsoft-com:office:powerpoint" xmlns:v="urn:schemas-microsoft-com:vml" xmlns:o="urn:schemas-microsoft-com:office:office" xmlns:dgm="http://schemas.openxmlformats.org/drawingml/2006/diagram" xmlns:c="http://schemas.openxmlformats.org/drawingml/2006/chart" xmlns:mv="urn:schemas-microsoft-com:mac:vml" xmlns:mc="http://schemas.openxmlformats.org/markup-compatibility/2006" xmlns="" r:id="rId20" roundtripDataSignature="AMtx7mjKkk5wOoQj6sDPPETbbKgHU96Dzg=="/>
     </p:ext>
   </p:extLst>
 </p:presentation>
@@ -1829,6 +1830,110 @@
   <p:cSld>
     <p:spTree>
       <p:nvGrpSpPr>
+        <p:cNvPr id="1" name="Shape 190"/>
+        <p:cNvGrpSpPr/>
+        <p:nvPr/>
+      </p:nvGrpSpPr>
+      <p:grpSpPr>
+        <a:xfrm>
+          <a:off x="0" y="0"/>
+          <a:ext cx="0" cy="0"/>
+          <a:chOff x="0" y="0"/>
+          <a:chExt cx="0" cy="0"/>
+        </a:xfrm>
+      </p:grpSpPr>
+      <p:sp>
+        <p:nvSpPr>
+          <p:cNvPr id="191" name="Google Shape;191;p33:notes"/>
+          <p:cNvSpPr txBox="1">
+            <a:spLocks noGrp="1"/>
+          </p:cNvSpPr>
+          <p:nvPr>
+            <p:ph type="body" idx="1"/>
+          </p:nvPr>
+        </p:nvSpPr>
+        <p:spPr>
+          <a:xfrm>
+            <a:off x="685800" y="4400550"/>
+            <a:ext cx="5486400" cy="3600450"/>
+          </a:xfrm>
+          <a:prstGeom prst="rect">
+            <a:avLst/>
+          </a:prstGeom>
+        </p:spPr>
+        <p:txBody>
+          <a:bodyPr spcFirstLastPara="1" wrap="square" lIns="91425" tIns="45700" rIns="91425" bIns="45700" anchor="t" anchorCtr="0">
+            <a:noAutofit/>
+          </a:bodyPr>
+          <a:lstStyle/>
+          <a:p>
+            <a:pPr marL="0" lvl="0" indent="0" algn="l" rtl="0">
+              <a:spcBef>
+                <a:spcPts val="0"/>
+              </a:spcBef>
+              <a:spcAft>
+                <a:spcPts val="0"/>
+              </a:spcAft>
+              <a:buNone/>
+            </a:pPr>
+            <a:endParaRPr/>
+          </a:p>
+        </p:txBody>
+      </p:sp>
+      <p:sp>
+        <p:nvSpPr>
+          <p:cNvPr id="192" name="Google Shape;192;p33:notes"/>
+          <p:cNvSpPr>
+            <a:spLocks noGrp="1" noRot="1" noChangeAspect="1"/>
+          </p:cNvSpPr>
+          <p:nvPr>
+            <p:ph type="sldImg" idx="2"/>
+          </p:nvPr>
+        </p:nvSpPr>
+        <p:spPr>
+          <a:xfrm>
+            <a:off x="685800" y="1143000"/>
+            <a:ext cx="5486400" cy="3086100"/>
+          </a:xfrm>
+          <a:custGeom>
+            <a:avLst/>
+            <a:gdLst/>
+            <a:ahLst/>
+            <a:cxnLst/>
+            <a:rect l="l" t="t" r="r" b="b"/>
+            <a:pathLst>
+              <a:path w="120000" h="120000" extrusionOk="0">
+                <a:moveTo>
+                  <a:pt x="0" y="0"/>
+                </a:moveTo>
+                <a:lnTo>
+                  <a:pt x="120000" y="0"/>
+                </a:lnTo>
+                <a:lnTo>
+                  <a:pt x="120000" y="120000"/>
+                </a:lnTo>
+                <a:lnTo>
+                  <a:pt x="0" y="120000"/>
+                </a:lnTo>
+                <a:close/>
+              </a:path>
+            </a:pathLst>
+          </a:custGeom>
+        </p:spPr>
+      </p:sp>
+    </p:spTree>
+  </p:cSld>
+  <p:clrMapOvr>
+    <a:masterClrMapping/>
+  </p:clrMapOvr>
+</p:notes>
+</file>
+
+<file path=ppt/notesSlides/notesSlide11.xml><?xml version="1.0" encoding="utf-8"?>
+<p:notes xmlns:a="http://schemas.openxmlformats.org/drawingml/2006/main" xmlns:r="http://schemas.openxmlformats.org/officeDocument/2006/relationships" xmlns:p="http://schemas.openxmlformats.org/presentationml/2006/main" showMasterSp="0" showMasterPhAnim="0">
+  <p:cSld>
+    <p:spTree>
+      <p:nvGrpSpPr>
         <p:cNvPr id="1" name="Shape 205"/>
         <p:cNvGrpSpPr/>
         <p:nvPr/>
@@ -1946,7 +2051,7 @@
 </p:notes>
 </file>
 
-<file path=ppt/notesSlides/notesSlide11.xml><?xml version="1.0" encoding="utf-8"?>
+<file path=ppt/notesSlides/notesSlide12.xml><?xml version="1.0" encoding="utf-8"?>
 <p:notes xmlns:a="http://schemas.openxmlformats.org/drawingml/2006/main" xmlns:r="http://schemas.openxmlformats.org/officeDocument/2006/relationships" xmlns:p="http://schemas.openxmlformats.org/presentationml/2006/main" showMasterSp="0" showMasterPhAnim="0">
   <p:cSld>
     <p:spTree>
@@ -2050,7 +2155,7 @@
 </p:notes>
 </file>
 
-<file path=ppt/notesSlides/notesSlide12.xml><?xml version="1.0" encoding="utf-8"?>
+<file path=ppt/notesSlides/notesSlide13.xml><?xml version="1.0" encoding="utf-8"?>
 <p:notes xmlns:a="http://schemas.openxmlformats.org/drawingml/2006/main" xmlns:r="http://schemas.openxmlformats.org/officeDocument/2006/relationships" xmlns:p="http://schemas.openxmlformats.org/presentationml/2006/main" showMasterSp="0" showMasterPhAnim="0">
   <p:cSld>
     <p:spTree>
@@ -2154,7 +2259,7 @@
 </p:notes>
 </file>
 
-<file path=ppt/notesSlides/notesSlide13.xml><?xml version="1.0" encoding="utf-8"?>
+<file path=ppt/notesSlides/notesSlide14.xml><?xml version="1.0" encoding="utf-8"?>
 <p:notes xmlns:a="http://schemas.openxmlformats.org/drawingml/2006/main" xmlns:r="http://schemas.openxmlformats.org/officeDocument/2006/relationships" xmlns:p="http://schemas.openxmlformats.org/presentationml/2006/main" showMasterSp="0" showMasterPhAnim="0">
   <p:cSld>
     <p:spTree>
@@ -2258,7 +2363,7 @@
 </p:notes>
 </file>
 
-<file path=ppt/notesSlides/notesSlide14.xml><?xml version="1.0" encoding="utf-8"?>
+<file path=ppt/notesSlides/notesSlide15.xml><?xml version="1.0" encoding="utf-8"?>
 <p:notes xmlns:a="http://schemas.openxmlformats.org/drawingml/2006/main" xmlns:r="http://schemas.openxmlformats.org/officeDocument/2006/relationships" xmlns:p="http://schemas.openxmlformats.org/presentationml/2006/main" showMasterSp="0" showMasterPhAnim="0">
   <p:cSld>
     <p:spTree>
@@ -2362,7 +2467,7 @@
 </p:notes>
 </file>
 
-<file path=ppt/notesSlides/notesSlide15.xml><?xml version="1.0" encoding="utf-8"?>
+<file path=ppt/notesSlides/notesSlide16.xml><?xml version="1.0" encoding="utf-8"?>
 <p:notes xmlns:a="http://schemas.openxmlformats.org/drawingml/2006/main" xmlns:r="http://schemas.openxmlformats.org/officeDocument/2006/relationships" xmlns:p="http://schemas.openxmlformats.org/presentationml/2006/main" showMasterSp="0" showMasterPhAnim="0">
   <p:cSld>
     <p:spTree>
@@ -2489,7 +2594,7 @@
 </p:notes>
 </file>
 
-<file path=ppt/notesSlides/notesSlide16.xml><?xml version="1.0" encoding="utf-8"?>
+<file path=ppt/notesSlides/notesSlide17.xml><?xml version="1.0" encoding="utf-8"?>
 <p:notes xmlns:a="http://schemas.openxmlformats.org/drawingml/2006/main" xmlns:r="http://schemas.openxmlformats.org/officeDocument/2006/relationships" xmlns:p="http://schemas.openxmlformats.org/presentationml/2006/main" showMasterSp="0" showMasterPhAnim="0">
   <p:cSld>
     <p:spTree>
@@ -2702,6 +2807,133 @@
   <p:cSld>
     <p:spTree>
       <p:nvGrpSpPr>
+        <p:cNvPr id="1" name="Shape 85">
+          <a:extLst>
+            <a:ext uri="{FF2B5EF4-FFF2-40B4-BE49-F238E27FC236}">
+              <a16:creationId xmlns:a16="http://schemas.microsoft.com/office/drawing/2014/main" id="{AF9ED5EC-765E-DDD7-332B-8A00B0540F98}"/>
+            </a:ext>
+          </a:extLst>
+        </p:cNvPr>
+        <p:cNvGrpSpPr/>
+        <p:nvPr/>
+      </p:nvGrpSpPr>
+      <p:grpSpPr>
+        <a:xfrm>
+          <a:off x="0" y="0"/>
+          <a:ext cx="0" cy="0"/>
+          <a:chOff x="0" y="0"/>
+          <a:chExt cx="0" cy="0"/>
+        </a:xfrm>
+      </p:grpSpPr>
+      <p:sp>
+        <p:nvSpPr>
+          <p:cNvPr id="86" name="Google Shape;86;p27:notes">
+            <a:extLst>
+              <a:ext uri="{FF2B5EF4-FFF2-40B4-BE49-F238E27FC236}">
+                <a16:creationId xmlns:a16="http://schemas.microsoft.com/office/drawing/2014/main" id="{5154540A-10BF-B029-D910-A380E44E1A04}"/>
+              </a:ext>
+            </a:extLst>
+          </p:cNvPr>
+          <p:cNvSpPr txBox="1">
+            <a:spLocks noGrp="1"/>
+          </p:cNvSpPr>
+          <p:nvPr>
+            <p:ph type="body" idx="1"/>
+          </p:nvPr>
+        </p:nvSpPr>
+        <p:spPr>
+          <a:xfrm>
+            <a:off x="685800" y="4400550"/>
+            <a:ext cx="5486400" cy="3600450"/>
+          </a:xfrm>
+          <a:prstGeom prst="rect">
+            <a:avLst/>
+          </a:prstGeom>
+        </p:spPr>
+        <p:txBody>
+          <a:bodyPr spcFirstLastPara="1" wrap="square" lIns="91425" tIns="45700" rIns="91425" bIns="45700" anchor="t" anchorCtr="0">
+            <a:noAutofit/>
+          </a:bodyPr>
+          <a:lstStyle/>
+          <a:p>
+            <a:pPr marL="0" lvl="0" indent="0" algn="l" rtl="0">
+              <a:spcBef>
+                <a:spcPts val="0"/>
+              </a:spcBef>
+              <a:spcAft>
+                <a:spcPts val="0"/>
+              </a:spcAft>
+              <a:buNone/>
+            </a:pPr>
+            <a:endParaRPr/>
+          </a:p>
+        </p:txBody>
+      </p:sp>
+      <p:sp>
+        <p:nvSpPr>
+          <p:cNvPr id="87" name="Google Shape;87;p27:notes">
+            <a:extLst>
+              <a:ext uri="{FF2B5EF4-FFF2-40B4-BE49-F238E27FC236}">
+                <a16:creationId xmlns:a16="http://schemas.microsoft.com/office/drawing/2014/main" id="{D65677FB-0014-3040-C794-160B4CD86AA2}"/>
+              </a:ext>
+            </a:extLst>
+          </p:cNvPr>
+          <p:cNvSpPr>
+            <a:spLocks noGrp="1" noRot="1" noChangeAspect="1"/>
+          </p:cNvSpPr>
+          <p:nvPr>
+            <p:ph type="sldImg" idx="2"/>
+          </p:nvPr>
+        </p:nvSpPr>
+        <p:spPr>
+          <a:xfrm>
+            <a:off x="685800" y="1143000"/>
+            <a:ext cx="5486400" cy="3086100"/>
+          </a:xfrm>
+          <a:custGeom>
+            <a:avLst/>
+            <a:gdLst/>
+            <a:ahLst/>
+            <a:cxnLst/>
+            <a:rect l="l" t="t" r="r" b="b"/>
+            <a:pathLst>
+              <a:path w="120000" h="120000" extrusionOk="0">
+                <a:moveTo>
+                  <a:pt x="0" y="0"/>
+                </a:moveTo>
+                <a:lnTo>
+                  <a:pt x="120000" y="0"/>
+                </a:lnTo>
+                <a:lnTo>
+                  <a:pt x="120000" y="120000"/>
+                </a:lnTo>
+                <a:lnTo>
+                  <a:pt x="0" y="120000"/>
+                </a:lnTo>
+                <a:close/>
+              </a:path>
+            </a:pathLst>
+          </a:custGeom>
+        </p:spPr>
+      </p:sp>
+    </p:spTree>
+    <p:extLst>
+      <p:ext uri="{BB962C8B-B14F-4D97-AF65-F5344CB8AC3E}">
+        <p14:creationId xmlns:p14="http://schemas.microsoft.com/office/powerpoint/2010/main" val="4025381610"/>
+      </p:ext>
+    </p:extLst>
+  </p:cSld>
+  <p:clrMapOvr>
+    <a:masterClrMapping/>
+  </p:clrMapOvr>
+</p:notes>
+</file>
+
+<file path=ppt/notesSlides/notesSlide4.xml><?xml version="1.0" encoding="utf-8"?>
+<p:notes xmlns:a="http://schemas.openxmlformats.org/drawingml/2006/main" xmlns:r="http://schemas.openxmlformats.org/officeDocument/2006/relationships" xmlns:p="http://schemas.openxmlformats.org/presentationml/2006/main" showMasterSp="0" showMasterPhAnim="0">
+  <p:cSld>
+    <p:spTree>
+      <p:nvGrpSpPr>
         <p:cNvPr id="1" name="Shape 100"/>
         <p:cNvGrpSpPr/>
         <p:nvPr/>
@@ -2801,7 +3033,7 @@
 </p:notes>
 </file>
 
-<file path=ppt/notesSlides/notesSlide4.xml><?xml version="1.0" encoding="utf-8"?>
+<file path=ppt/notesSlides/notesSlide5.xml><?xml version="1.0" encoding="utf-8"?>
 <p:notes xmlns:a="http://schemas.openxmlformats.org/drawingml/2006/main" xmlns:r="http://schemas.openxmlformats.org/officeDocument/2006/relationships" xmlns:p="http://schemas.openxmlformats.org/presentationml/2006/main" showMasterSp="0" showMasterPhAnim="0">
   <p:cSld>
     <p:spTree>
@@ -2923,7 +3155,7 @@
 </p:notes>
 </file>
 
-<file path=ppt/notesSlides/notesSlide5.xml><?xml version="1.0" encoding="utf-8"?>
+<file path=ppt/notesSlides/notesSlide6.xml><?xml version="1.0" encoding="utf-8"?>
 <p:notes xmlns:a="http://schemas.openxmlformats.org/drawingml/2006/main" xmlns:r="http://schemas.openxmlformats.org/officeDocument/2006/relationships" xmlns:p="http://schemas.openxmlformats.org/presentationml/2006/main" showMasterSp="0" showMasterPhAnim="0">
   <p:cSld>
     <p:spTree>
@@ -3027,7 +3259,7 @@
 </p:notes>
 </file>
 
-<file path=ppt/notesSlides/notesSlide6.xml><?xml version="1.0" encoding="utf-8"?>
+<file path=ppt/notesSlides/notesSlide7.xml><?xml version="1.0" encoding="utf-8"?>
 <p:notes xmlns:a="http://schemas.openxmlformats.org/drawingml/2006/main" xmlns:r="http://schemas.openxmlformats.org/officeDocument/2006/relationships" xmlns:p="http://schemas.openxmlformats.org/presentationml/2006/main" showMasterSp="0" showMasterPhAnim="0">
   <p:cSld>
     <p:spTree>
@@ -3131,7 +3363,7 @@
 </p:notes>
 </file>
 
-<file path=ppt/notesSlides/notesSlide7.xml><?xml version="1.0" encoding="utf-8"?>
+<file path=ppt/notesSlides/notesSlide8.xml><?xml version="1.0" encoding="utf-8"?>
 <p:notes xmlns:a="http://schemas.openxmlformats.org/drawingml/2006/main" xmlns:r="http://schemas.openxmlformats.org/officeDocument/2006/relationships" xmlns:p="http://schemas.openxmlformats.org/presentationml/2006/main" showMasterSp="0" showMasterPhAnim="0">
   <p:cSld>
     <p:spTree>
@@ -3253,7 +3485,7 @@
 </p:notes>
 </file>
 
-<file path=ppt/notesSlides/notesSlide8.xml><?xml version="1.0" encoding="utf-8"?>
+<file path=ppt/notesSlides/notesSlide9.xml><?xml version="1.0" encoding="utf-8"?>
 <p:notes xmlns:a="http://schemas.openxmlformats.org/drawingml/2006/main" xmlns:r="http://schemas.openxmlformats.org/officeDocument/2006/relationships" xmlns:p="http://schemas.openxmlformats.org/presentationml/2006/main" showMasterSp="0" showMasterPhAnim="0">
   <p:cSld>
     <p:spTree>
@@ -3311,110 +3543,6 @@
       <p:sp>
         <p:nvSpPr>
           <p:cNvPr id="177" name="Google Shape;177;p32:notes"/>
-          <p:cNvSpPr>
-            <a:spLocks noGrp="1" noRot="1" noChangeAspect="1"/>
-          </p:cNvSpPr>
-          <p:nvPr>
-            <p:ph type="sldImg" idx="2"/>
-          </p:nvPr>
-        </p:nvSpPr>
-        <p:spPr>
-          <a:xfrm>
-            <a:off x="685800" y="1143000"/>
-            <a:ext cx="5486400" cy="3086100"/>
-          </a:xfrm>
-          <a:custGeom>
-            <a:avLst/>
-            <a:gdLst/>
-            <a:ahLst/>
-            <a:cxnLst/>
-            <a:rect l="l" t="t" r="r" b="b"/>
-            <a:pathLst>
-              <a:path w="120000" h="120000" extrusionOk="0">
-                <a:moveTo>
-                  <a:pt x="0" y="0"/>
-                </a:moveTo>
-                <a:lnTo>
-                  <a:pt x="120000" y="0"/>
-                </a:lnTo>
-                <a:lnTo>
-                  <a:pt x="120000" y="120000"/>
-                </a:lnTo>
-                <a:lnTo>
-                  <a:pt x="0" y="120000"/>
-                </a:lnTo>
-                <a:close/>
-              </a:path>
-            </a:pathLst>
-          </a:custGeom>
-        </p:spPr>
-      </p:sp>
-    </p:spTree>
-  </p:cSld>
-  <p:clrMapOvr>
-    <a:masterClrMapping/>
-  </p:clrMapOvr>
-</p:notes>
-</file>
-
-<file path=ppt/notesSlides/notesSlide9.xml><?xml version="1.0" encoding="utf-8"?>
-<p:notes xmlns:a="http://schemas.openxmlformats.org/drawingml/2006/main" xmlns:r="http://schemas.openxmlformats.org/officeDocument/2006/relationships" xmlns:p="http://schemas.openxmlformats.org/presentationml/2006/main" showMasterSp="0" showMasterPhAnim="0">
-  <p:cSld>
-    <p:spTree>
-      <p:nvGrpSpPr>
-        <p:cNvPr id="1" name="Shape 190"/>
-        <p:cNvGrpSpPr/>
-        <p:nvPr/>
-      </p:nvGrpSpPr>
-      <p:grpSpPr>
-        <a:xfrm>
-          <a:off x="0" y="0"/>
-          <a:ext cx="0" cy="0"/>
-          <a:chOff x="0" y="0"/>
-          <a:chExt cx="0" cy="0"/>
-        </a:xfrm>
-      </p:grpSpPr>
-      <p:sp>
-        <p:nvSpPr>
-          <p:cNvPr id="191" name="Google Shape;191;p33:notes"/>
-          <p:cNvSpPr txBox="1">
-            <a:spLocks noGrp="1"/>
-          </p:cNvSpPr>
-          <p:nvPr>
-            <p:ph type="body" idx="1"/>
-          </p:nvPr>
-        </p:nvSpPr>
-        <p:spPr>
-          <a:xfrm>
-            <a:off x="685800" y="4400550"/>
-            <a:ext cx="5486400" cy="3600450"/>
-          </a:xfrm>
-          <a:prstGeom prst="rect">
-            <a:avLst/>
-          </a:prstGeom>
-        </p:spPr>
-        <p:txBody>
-          <a:bodyPr spcFirstLastPara="1" wrap="square" lIns="91425" tIns="45700" rIns="91425" bIns="45700" anchor="t" anchorCtr="0">
-            <a:noAutofit/>
-          </a:bodyPr>
-          <a:lstStyle/>
-          <a:p>
-            <a:pPr marL="0" lvl="0" indent="0" algn="l" rtl="0">
-              <a:spcBef>
-                <a:spcPts val="0"/>
-              </a:spcBef>
-              <a:spcAft>
-                <a:spcPts val="0"/>
-              </a:spcAft>
-              <a:buNone/>
-            </a:pPr>
-            <a:endParaRPr/>
-          </a:p>
-        </p:txBody>
-      </p:sp>
-      <p:sp>
-        <p:nvSpPr>
-          <p:cNvPr id="192" name="Google Shape;192;p33:notes"/>
           <p:cNvSpPr>
             <a:spLocks noGrp="1" noRot="1" noChangeAspect="1"/>
           </p:cNvSpPr>
@@ -16028,6 +16156,723 @@
   <p:cSld>
     <p:spTree>
       <p:nvGrpSpPr>
+        <p:cNvPr id="1" name="Shape 193"/>
+        <p:cNvGrpSpPr/>
+        <p:nvPr/>
+      </p:nvGrpSpPr>
+      <p:grpSpPr>
+        <a:xfrm>
+          <a:off x="0" y="0"/>
+          <a:ext cx="0" cy="0"/>
+          <a:chOff x="0" y="0"/>
+          <a:chExt cx="0" cy="0"/>
+        </a:xfrm>
+      </p:grpSpPr>
+      <p:sp>
+        <p:nvSpPr>
+          <p:cNvPr id="194" name="Google Shape;194;p33"/>
+          <p:cNvSpPr/>
+          <p:nvPr/>
+        </p:nvSpPr>
+        <p:spPr>
+          <a:xfrm>
+            <a:off x="7452352" y="1263718"/>
+            <a:ext cx="4356660" cy="4825998"/>
+          </a:xfrm>
+          <a:prstGeom prst="rect">
+            <a:avLst/>
+          </a:prstGeom>
+          <a:solidFill>
+            <a:srgbClr val="D8D8D8"/>
+          </a:solidFill>
+          <a:ln>
+            <a:noFill/>
+          </a:ln>
+        </p:spPr>
+        <p:txBody>
+          <a:bodyPr spcFirstLastPara="1" wrap="square" lIns="91425" tIns="45700" rIns="91425" bIns="45700" anchor="ctr" anchorCtr="0">
+            <a:noAutofit/>
+          </a:bodyPr>
+          <a:lstStyle/>
+          <a:p>
+            <a:pPr marL="0" marR="0" lvl="0" indent="0" algn="ctr" rtl="0">
+              <a:lnSpc>
+                <a:spcPct val="100000"/>
+              </a:lnSpc>
+              <a:spcBef>
+                <a:spcPts val="0"/>
+              </a:spcBef>
+              <a:spcAft>
+                <a:spcPts val="0"/>
+              </a:spcAft>
+              <a:buClr>
+                <a:srgbClr val="000000"/>
+              </a:buClr>
+              <a:buSzPts val="1800"/>
+              <a:buFont typeface="Arial"/>
+              <a:buNone/>
+            </a:pPr>
+            <a:endParaRPr sz="1800" b="0" i="0" u="none" strike="noStrike" cap="none">
+              <a:solidFill>
+                <a:schemeClr val="lt1"/>
+              </a:solidFill>
+              <a:latin typeface="Calibri"/>
+              <a:ea typeface="Calibri"/>
+              <a:cs typeface="Calibri"/>
+              <a:sym typeface="Calibri"/>
+            </a:endParaRPr>
+          </a:p>
+        </p:txBody>
+      </p:sp>
+      <p:sp>
+        <p:nvSpPr>
+          <p:cNvPr id="195" name="Google Shape;195;p33"/>
+          <p:cNvSpPr txBox="1"/>
+          <p:nvPr/>
+        </p:nvSpPr>
+        <p:spPr>
+          <a:xfrm>
+            <a:off x="8490436" y="3493224"/>
+            <a:ext cx="2280491" cy="369332"/>
+          </a:xfrm>
+          <a:prstGeom prst="rect">
+            <a:avLst/>
+          </a:prstGeom>
+          <a:noFill/>
+          <a:ln>
+            <a:noFill/>
+          </a:ln>
+        </p:spPr>
+        <p:txBody>
+          <a:bodyPr spcFirstLastPara="1" wrap="square" lIns="91425" tIns="45700" rIns="91425" bIns="45700" anchor="t" anchorCtr="0">
+            <a:spAutoFit/>
+          </a:bodyPr>
+          <a:lstStyle/>
+          <a:p>
+            <a:pPr marL="0" marR="0" lvl="0" indent="0" algn="ctr" rtl="0">
+              <a:lnSpc>
+                <a:spcPct val="100000"/>
+              </a:lnSpc>
+              <a:spcBef>
+                <a:spcPts val="0"/>
+              </a:spcBef>
+              <a:spcAft>
+                <a:spcPts val="0"/>
+              </a:spcAft>
+              <a:buClr>
+                <a:srgbClr val="000000"/>
+              </a:buClr>
+              <a:buSzPts val="1800"/>
+              <a:buFont typeface="Arial"/>
+              <a:buNone/>
+            </a:pPr>
+            <a:r>
+              <a:rPr lang="en-US" sz="1800" b="0" i="0" u="none" strike="noStrike" cap="none">
+                <a:solidFill>
+                  <a:srgbClr val="A5A5A5"/>
+                </a:solidFill>
+                <a:latin typeface="Arial"/>
+                <a:ea typeface="Arial"/>
+                <a:cs typeface="Arial"/>
+                <a:sym typeface="Arial"/>
+              </a:rPr>
+              <a:t>IMAGE / GRAPHIC</a:t>
+            </a:r>
+            <a:endParaRPr sz="1400" b="0" i="0" u="none" strike="noStrike" cap="none">
+              <a:solidFill>
+                <a:srgbClr val="000000"/>
+              </a:solidFill>
+              <a:latin typeface="Arial"/>
+              <a:ea typeface="Arial"/>
+              <a:cs typeface="Arial"/>
+              <a:sym typeface="Arial"/>
+            </a:endParaRPr>
+          </a:p>
+        </p:txBody>
+      </p:sp>
+      <p:sp>
+        <p:nvSpPr>
+          <p:cNvPr id="196" name="Google Shape;196;p33"/>
+          <p:cNvSpPr txBox="1"/>
+          <p:nvPr/>
+        </p:nvSpPr>
+        <p:spPr>
+          <a:xfrm>
+            <a:off x="376808" y="1334279"/>
+            <a:ext cx="6422373" cy="4821102"/>
+          </a:xfrm>
+          <a:prstGeom prst="rect">
+            <a:avLst/>
+          </a:prstGeom>
+          <a:noFill/>
+          <a:ln>
+            <a:noFill/>
+          </a:ln>
+        </p:spPr>
+        <p:txBody>
+          <a:bodyPr spcFirstLastPara="1" wrap="square" lIns="91425" tIns="45700" rIns="91425" bIns="45700" anchor="t" anchorCtr="0">
+            <a:noAutofit/>
+          </a:bodyPr>
+          <a:lstStyle/>
+          <a:p>
+            <a:pPr marL="0" marR="0" lvl="0" indent="0" algn="l" rtl="0">
+              <a:lnSpc>
+                <a:spcPct val="100000"/>
+              </a:lnSpc>
+              <a:spcBef>
+                <a:spcPts val="0"/>
+              </a:spcBef>
+              <a:spcAft>
+                <a:spcPts val="0"/>
+              </a:spcAft>
+              <a:buNone/>
+            </a:pPr>
+            <a:r>
+              <a:rPr lang="en-US" sz="2600" b="1" i="0" u="none" strike="noStrike" cap="none">
+                <a:solidFill>
+                  <a:srgbClr val="E84B36"/>
+                </a:solidFill>
+                <a:latin typeface="Arial"/>
+                <a:ea typeface="Arial"/>
+                <a:cs typeface="Arial"/>
+                <a:sym typeface="Arial"/>
+              </a:rPr>
+              <a:t>Lorem Ipsum Dolor Sit Amet Consectetur Adipiscing</a:t>
+            </a:r>
+            <a:endParaRPr sz="2600" b="1" i="0" u="none" strike="noStrike" cap="none">
+              <a:solidFill>
+                <a:srgbClr val="E84B36"/>
+              </a:solidFill>
+              <a:latin typeface="Arial"/>
+              <a:ea typeface="Arial"/>
+              <a:cs typeface="Arial"/>
+              <a:sym typeface="Arial"/>
+            </a:endParaRPr>
+          </a:p>
+          <a:p>
+            <a:pPr marL="0" marR="0" lvl="0" indent="0" algn="l" rtl="0">
+              <a:lnSpc>
+                <a:spcPct val="100000"/>
+              </a:lnSpc>
+              <a:spcBef>
+                <a:spcPts val="0"/>
+              </a:spcBef>
+              <a:spcAft>
+                <a:spcPts val="0"/>
+              </a:spcAft>
+              <a:buNone/>
+            </a:pPr>
+            <a:endParaRPr sz="1800" b="0" i="0" u="none" strike="noStrike" cap="none">
+              <a:solidFill>
+                <a:schemeClr val="dk1"/>
+              </a:solidFill>
+              <a:latin typeface="Arial"/>
+              <a:ea typeface="Arial"/>
+              <a:cs typeface="Arial"/>
+              <a:sym typeface="Arial"/>
+            </a:endParaRPr>
+          </a:p>
+          <a:p>
+            <a:pPr marL="0" marR="0" lvl="0" indent="0" algn="l" rtl="0">
+              <a:lnSpc>
+                <a:spcPct val="100000"/>
+              </a:lnSpc>
+              <a:spcBef>
+                <a:spcPts val="0"/>
+              </a:spcBef>
+              <a:spcAft>
+                <a:spcPts val="0"/>
+              </a:spcAft>
+              <a:buNone/>
+            </a:pPr>
+            <a:r>
+              <a:rPr lang="en-US" sz="1800" b="0" i="0" u="none" strike="noStrike" cap="none">
+                <a:solidFill>
+                  <a:srgbClr val="000000"/>
+                </a:solidFill>
+                <a:latin typeface="Arial"/>
+                <a:ea typeface="Arial"/>
+                <a:cs typeface="Arial"/>
+                <a:sym typeface="Arial"/>
+              </a:rPr>
+              <a:t>Lorem ipsum dolor sit amet, consectetur adipiscing elit, sed do eiusmod tempor incididunt ut labore et dolore magna aliqua. Ut enim ad minim veniam, quis nostrud exercitation ullamco laboris nisi ut aliquip ex ea commodo consequat. </a:t>
+            </a:r>
+            <a:endParaRPr/>
+          </a:p>
+          <a:p>
+            <a:pPr marL="0" marR="0" lvl="0" indent="0" algn="l" rtl="0">
+              <a:lnSpc>
+                <a:spcPct val="100000"/>
+              </a:lnSpc>
+              <a:spcBef>
+                <a:spcPts val="0"/>
+              </a:spcBef>
+              <a:spcAft>
+                <a:spcPts val="0"/>
+              </a:spcAft>
+              <a:buNone/>
+            </a:pPr>
+            <a:endParaRPr sz="1800" b="0" i="0" u="none" strike="noStrike" cap="none">
+              <a:solidFill>
+                <a:schemeClr val="dk1"/>
+              </a:solidFill>
+              <a:latin typeface="Arial"/>
+              <a:ea typeface="Arial"/>
+              <a:cs typeface="Arial"/>
+              <a:sym typeface="Arial"/>
+            </a:endParaRPr>
+          </a:p>
+          <a:p>
+            <a:pPr marL="0" marR="0" lvl="0" indent="0" algn="l" rtl="0">
+              <a:lnSpc>
+                <a:spcPct val="100000"/>
+              </a:lnSpc>
+              <a:spcBef>
+                <a:spcPts val="0"/>
+              </a:spcBef>
+              <a:spcAft>
+                <a:spcPts val="0"/>
+              </a:spcAft>
+              <a:buNone/>
+            </a:pPr>
+            <a:r>
+              <a:rPr lang="en-US" sz="2000" b="1" i="0" u="none" strike="noStrike" cap="none">
+                <a:solidFill>
+                  <a:srgbClr val="15264B"/>
+                </a:solidFill>
+                <a:latin typeface="Arial"/>
+                <a:ea typeface="Arial"/>
+                <a:cs typeface="Arial"/>
+                <a:sym typeface="Arial"/>
+              </a:rPr>
+              <a:t>Lorem Ipsum Dolor Sit Amet Consectetur Adipiscing</a:t>
+            </a:r>
+            <a:endParaRPr sz="2000" b="1" i="0" u="none" strike="noStrike" cap="none">
+              <a:solidFill>
+                <a:srgbClr val="15264B"/>
+              </a:solidFill>
+              <a:latin typeface="Arial"/>
+              <a:ea typeface="Arial"/>
+              <a:cs typeface="Arial"/>
+              <a:sym typeface="Arial"/>
+            </a:endParaRPr>
+          </a:p>
+          <a:p>
+            <a:pPr marL="0" marR="0" lvl="0" indent="0" algn="l" rtl="0">
+              <a:lnSpc>
+                <a:spcPct val="100000"/>
+              </a:lnSpc>
+              <a:spcBef>
+                <a:spcPts val="0"/>
+              </a:spcBef>
+              <a:spcAft>
+                <a:spcPts val="0"/>
+              </a:spcAft>
+              <a:buNone/>
+            </a:pPr>
+            <a:endParaRPr sz="1800" b="1" i="0" u="none" strike="noStrike" cap="none">
+              <a:solidFill>
+                <a:schemeClr val="dk1"/>
+              </a:solidFill>
+              <a:latin typeface="Arial"/>
+              <a:ea typeface="Arial"/>
+              <a:cs typeface="Arial"/>
+              <a:sym typeface="Arial"/>
+            </a:endParaRPr>
+          </a:p>
+          <a:p>
+            <a:pPr marL="0" marR="0" lvl="0" indent="0" algn="l" rtl="0">
+              <a:lnSpc>
+                <a:spcPct val="100000"/>
+              </a:lnSpc>
+              <a:spcBef>
+                <a:spcPts val="0"/>
+              </a:spcBef>
+              <a:spcAft>
+                <a:spcPts val="0"/>
+              </a:spcAft>
+              <a:buNone/>
+            </a:pPr>
+            <a:r>
+              <a:rPr lang="en-US" sz="1800" b="0" i="0" u="none" strike="noStrike" cap="none">
+                <a:solidFill>
+                  <a:srgbClr val="000000"/>
+                </a:solidFill>
+                <a:latin typeface="Arial"/>
+                <a:ea typeface="Arial"/>
+                <a:cs typeface="Arial"/>
+                <a:sym typeface="Arial"/>
+              </a:rPr>
+              <a:t>Lorem ipsum dolor sit amet, consectetur adipiscing elit, sed do eiusmod tempor incididunt ut labore et dolore magna aliqua.</a:t>
+            </a:r>
+            <a:endParaRPr sz="1800" b="1" i="0" u="none" strike="noStrike" cap="none">
+              <a:solidFill>
+                <a:schemeClr val="dk1"/>
+              </a:solidFill>
+              <a:latin typeface="Arial"/>
+              <a:ea typeface="Arial"/>
+              <a:cs typeface="Arial"/>
+              <a:sym typeface="Arial"/>
+            </a:endParaRPr>
+          </a:p>
+        </p:txBody>
+      </p:sp>
+      <p:sp>
+        <p:nvSpPr>
+          <p:cNvPr id="197" name="Google Shape;197;p33"/>
+          <p:cNvSpPr/>
+          <p:nvPr/>
+        </p:nvSpPr>
+        <p:spPr>
+          <a:xfrm rot="10800000" flipH="1">
+            <a:off x="0" y="0"/>
+            <a:ext cx="12192000" cy="868220"/>
+          </a:xfrm>
+          <a:prstGeom prst="rect">
+            <a:avLst/>
+          </a:prstGeom>
+          <a:solidFill>
+            <a:srgbClr val="13294B"/>
+          </a:solidFill>
+          <a:ln>
+            <a:noFill/>
+          </a:ln>
+        </p:spPr>
+        <p:txBody>
+          <a:bodyPr spcFirstLastPara="1" wrap="square" lIns="91425" tIns="45700" rIns="91425" bIns="45700" anchor="ctr" anchorCtr="0">
+            <a:noAutofit/>
+          </a:bodyPr>
+          <a:lstStyle/>
+          <a:p>
+            <a:pPr marL="0" marR="0" lvl="0" indent="0" algn="ctr" rtl="0">
+              <a:lnSpc>
+                <a:spcPct val="100000"/>
+              </a:lnSpc>
+              <a:spcBef>
+                <a:spcPts val="0"/>
+              </a:spcBef>
+              <a:spcAft>
+                <a:spcPts val="0"/>
+              </a:spcAft>
+              <a:buClr>
+                <a:schemeClr val="lt1"/>
+              </a:buClr>
+              <a:buSzPts val="1800"/>
+              <a:buFont typeface="Calibri"/>
+              <a:buNone/>
+            </a:pPr>
+            <a:endParaRPr sz="1800" b="0" i="0" u="none" strike="noStrike" cap="none">
+              <a:solidFill>
+                <a:srgbClr val="13294B"/>
+              </a:solidFill>
+              <a:latin typeface="Calibri"/>
+              <a:ea typeface="Calibri"/>
+              <a:cs typeface="Calibri"/>
+              <a:sym typeface="Calibri"/>
+            </a:endParaRPr>
+          </a:p>
+        </p:txBody>
+      </p:sp>
+      <p:sp>
+        <p:nvSpPr>
+          <p:cNvPr id="198" name="Google Shape;198;p33"/>
+          <p:cNvSpPr txBox="1"/>
+          <p:nvPr/>
+        </p:nvSpPr>
+        <p:spPr>
+          <a:xfrm>
+            <a:off x="376810" y="204051"/>
+            <a:ext cx="10910026" cy="461624"/>
+          </a:xfrm>
+          <a:prstGeom prst="rect">
+            <a:avLst/>
+          </a:prstGeom>
+          <a:noFill/>
+          <a:ln>
+            <a:noFill/>
+          </a:ln>
+        </p:spPr>
+        <p:txBody>
+          <a:bodyPr spcFirstLastPara="1" wrap="square" lIns="91425" tIns="45700" rIns="91425" bIns="45700" anchor="t" anchorCtr="0">
+            <a:spAutoFit/>
+          </a:bodyPr>
+          <a:lstStyle/>
+          <a:p>
+            <a:pPr marL="0" marR="0" lvl="0" indent="0" algn="l" rtl="0">
+              <a:lnSpc>
+                <a:spcPct val="100000"/>
+              </a:lnSpc>
+              <a:spcBef>
+                <a:spcPts val="0"/>
+              </a:spcBef>
+              <a:spcAft>
+                <a:spcPts val="0"/>
+              </a:spcAft>
+              <a:buClr>
+                <a:srgbClr val="000000"/>
+              </a:buClr>
+              <a:buSzPts val="2400"/>
+              <a:buFont typeface="Arial"/>
+              <a:buNone/>
+            </a:pPr>
+            <a:r>
+              <a:rPr lang="en-US" sz="2400" b="0" i="0" u="none" strike="noStrike" cap="none">
+                <a:solidFill>
+                  <a:schemeClr val="lt1"/>
+                </a:solidFill>
+                <a:latin typeface="Arial"/>
+                <a:ea typeface="Arial"/>
+                <a:cs typeface="Arial"/>
+                <a:sym typeface="Arial"/>
+              </a:rPr>
+              <a:t>Slide Title</a:t>
+            </a:r>
+            <a:endParaRPr sz="2400" b="0" i="0" u="none" strike="noStrike" cap="none">
+              <a:solidFill>
+                <a:schemeClr val="lt1"/>
+              </a:solidFill>
+              <a:latin typeface="Arial"/>
+              <a:ea typeface="Arial"/>
+              <a:cs typeface="Arial"/>
+              <a:sym typeface="Arial"/>
+            </a:endParaRPr>
+          </a:p>
+        </p:txBody>
+      </p:sp>
+      <p:pic>
+        <p:nvPicPr>
+          <p:cNvPr id="199" name="Google Shape;199;p33"/>
+          <p:cNvPicPr preferRelativeResize="0"/>
+          <p:nvPr/>
+        </p:nvPicPr>
+        <p:blipFill rotWithShape="1">
+          <a:blip r:embed="rId3">
+            <a:alphaModFix/>
+          </a:blip>
+          <a:srcRect/>
+          <a:stretch/>
+        </p:blipFill>
+        <p:spPr>
+          <a:xfrm>
+            <a:off x="11557509" y="233819"/>
+            <a:ext cx="271308" cy="389810"/>
+          </a:xfrm>
+          <a:prstGeom prst="rect">
+            <a:avLst/>
+          </a:prstGeom>
+          <a:noFill/>
+          <a:ln>
+            <a:noFill/>
+          </a:ln>
+        </p:spPr>
+      </p:pic>
+      <p:sp>
+        <p:nvSpPr>
+          <p:cNvPr id="200" name="Google Shape;200;p33"/>
+          <p:cNvSpPr txBox="1"/>
+          <p:nvPr/>
+        </p:nvSpPr>
+        <p:spPr>
+          <a:xfrm>
+            <a:off x="9335597" y="6524381"/>
+            <a:ext cx="2473415" cy="230792"/>
+          </a:xfrm>
+          <a:prstGeom prst="rect">
+            <a:avLst/>
+          </a:prstGeom>
+          <a:noFill/>
+          <a:ln>
+            <a:noFill/>
+          </a:ln>
+        </p:spPr>
+        <p:txBody>
+          <a:bodyPr spcFirstLastPara="1" wrap="square" lIns="91425" tIns="45700" rIns="91425" bIns="45700" anchor="t" anchorCtr="0">
+            <a:spAutoFit/>
+          </a:bodyPr>
+          <a:lstStyle/>
+          <a:p>
+            <a:pPr marL="0" marR="0" lvl="0" indent="0" algn="r" rtl="0">
+              <a:lnSpc>
+                <a:spcPct val="100000"/>
+              </a:lnSpc>
+              <a:spcBef>
+                <a:spcPts val="0"/>
+              </a:spcBef>
+              <a:spcAft>
+                <a:spcPts val="0"/>
+              </a:spcAft>
+              <a:buNone/>
+            </a:pPr>
+            <a:r>
+              <a:rPr lang="en-US" sz="900" b="0" i="0" u="none" strike="noStrike" cap="none">
+                <a:solidFill>
+                  <a:srgbClr val="13294B"/>
+                </a:solidFill>
+                <a:latin typeface="Arial"/>
+                <a:ea typeface="Arial"/>
+                <a:cs typeface="Arial"/>
+                <a:sym typeface="Arial"/>
+              </a:rPr>
+              <a:t>GRAINGER ENGINEERING</a:t>
+            </a:r>
+            <a:endParaRPr/>
+          </a:p>
+        </p:txBody>
+      </p:sp>
+      <p:sp>
+        <p:nvSpPr>
+          <p:cNvPr id="201" name="Google Shape;201;p33"/>
+          <p:cNvSpPr txBox="1"/>
+          <p:nvPr/>
+        </p:nvSpPr>
+        <p:spPr>
+          <a:xfrm>
+            <a:off x="376807" y="6524381"/>
+            <a:ext cx="7991337" cy="230792"/>
+          </a:xfrm>
+          <a:prstGeom prst="rect">
+            <a:avLst/>
+          </a:prstGeom>
+          <a:noFill/>
+          <a:ln>
+            <a:noFill/>
+          </a:ln>
+        </p:spPr>
+        <p:txBody>
+          <a:bodyPr spcFirstLastPara="1" wrap="square" lIns="91425" tIns="45700" rIns="91425" bIns="45700" anchor="t" anchorCtr="0">
+            <a:spAutoFit/>
+          </a:bodyPr>
+          <a:lstStyle/>
+          <a:p>
+            <a:pPr marL="0" marR="0" lvl="0" indent="0" algn="l" rtl="0">
+              <a:lnSpc>
+                <a:spcPct val="100000"/>
+              </a:lnSpc>
+              <a:spcBef>
+                <a:spcPts val="0"/>
+              </a:spcBef>
+              <a:spcAft>
+                <a:spcPts val="0"/>
+              </a:spcAft>
+              <a:buNone/>
+            </a:pPr>
+            <a:r>
+              <a:rPr lang="en-US" sz="900" dirty="0">
+                <a:solidFill>
+                  <a:srgbClr val="13294B"/>
+                </a:solidFill>
+              </a:rPr>
+              <a:t>SYSTEMS ENGINEERING </a:t>
+            </a:r>
+            <a:endParaRPr dirty="0"/>
+          </a:p>
+        </p:txBody>
+      </p:sp>
+      <p:grpSp>
+        <p:nvGrpSpPr>
+          <p:cNvPr id="202" name="Google Shape;202;p33"/>
+          <p:cNvGrpSpPr/>
+          <p:nvPr/>
+        </p:nvGrpSpPr>
+        <p:grpSpPr>
+          <a:xfrm>
+            <a:off x="4066674" y="6601537"/>
+            <a:ext cx="5233412" cy="70446"/>
+            <a:chOff x="4033424" y="6601537"/>
+            <a:chExt cx="5233412" cy="70446"/>
+          </a:xfrm>
+        </p:grpSpPr>
+        <p:cxnSp>
+          <p:nvCxnSpPr>
+            <p:cNvPr id="203" name="Google Shape;203;p33"/>
+            <p:cNvCxnSpPr/>
+            <p:nvPr/>
+          </p:nvCxnSpPr>
+          <p:spPr>
+            <a:xfrm rot="10800000">
+              <a:off x="4033424" y="6639606"/>
+              <a:ext cx="5164651" cy="0"/>
+            </a:xfrm>
+            <a:prstGeom prst="straightConnector1">
+              <a:avLst/>
+            </a:prstGeom>
+            <a:noFill/>
+            <a:ln w="9525" cap="flat" cmpd="sng">
+              <a:solidFill>
+                <a:srgbClr val="13294B"/>
+              </a:solidFill>
+              <a:prstDash val="solid"/>
+              <a:round/>
+              <a:headEnd type="none" w="sm" len="sm"/>
+              <a:tailEnd type="none" w="sm" len="sm"/>
+            </a:ln>
+          </p:spPr>
+        </p:cxnSp>
+        <p:sp>
+          <p:nvSpPr>
+            <p:cNvPr id="204" name="Google Shape;204;p33"/>
+            <p:cNvSpPr/>
+            <p:nvPr/>
+          </p:nvSpPr>
+          <p:spPr>
+            <a:xfrm>
+              <a:off x="9196390" y="6601537"/>
+              <a:ext cx="70446" cy="70446"/>
+            </a:xfrm>
+            <a:prstGeom prst="ellipse">
+              <a:avLst/>
+            </a:prstGeom>
+            <a:solidFill>
+              <a:srgbClr val="13294B"/>
+            </a:solidFill>
+            <a:ln>
+              <a:noFill/>
+            </a:ln>
+          </p:spPr>
+          <p:txBody>
+            <a:bodyPr spcFirstLastPara="1" wrap="square" lIns="91425" tIns="45700" rIns="91425" bIns="45700" anchor="ctr" anchorCtr="0">
+              <a:noAutofit/>
+            </a:bodyPr>
+            <a:lstStyle/>
+            <a:p>
+              <a:pPr marL="0" marR="0" lvl="0" indent="0" algn="ctr" rtl="0">
+                <a:lnSpc>
+                  <a:spcPct val="100000"/>
+                </a:lnSpc>
+                <a:spcBef>
+                  <a:spcPts val="0"/>
+                </a:spcBef>
+                <a:spcAft>
+                  <a:spcPts val="0"/>
+                </a:spcAft>
+                <a:buNone/>
+              </a:pPr>
+              <a:endParaRPr sz="1400" b="0" i="0" u="none" strike="noStrike" cap="none">
+                <a:solidFill>
+                  <a:srgbClr val="13294B"/>
+                </a:solidFill>
+                <a:latin typeface="Arial"/>
+                <a:ea typeface="Arial"/>
+                <a:cs typeface="Arial"/>
+                <a:sym typeface="Arial"/>
+              </a:endParaRPr>
+            </a:p>
+          </p:txBody>
+        </p:sp>
+      </p:grpSp>
+    </p:spTree>
+  </p:cSld>
+  <p:clrMapOvr>
+    <a:masterClrMapping/>
+  </p:clrMapOvr>
+</p:sld>
+</file>
+
+<file path=ppt/slides/slide11.xml><?xml version="1.0" encoding="utf-8"?>
+<p:sld xmlns:a="http://schemas.openxmlformats.org/drawingml/2006/main" xmlns:r="http://schemas.openxmlformats.org/officeDocument/2006/relationships" xmlns:p="http://schemas.openxmlformats.org/presentationml/2006/main">
+  <p:cSld>
+    <p:spTree>
+      <p:nvGrpSpPr>
         <p:cNvPr id="1" name="Shape 208"/>
         <p:cNvGrpSpPr/>
         <p:nvPr/>
@@ -16579,7 +17424,7 @@
 </p:sld>
 </file>
 
-<file path=ppt/slides/slide11.xml><?xml version="1.0" encoding="utf-8"?>
+<file path=ppt/slides/slide12.xml><?xml version="1.0" encoding="utf-8"?>
 <p:sld xmlns:a="http://schemas.openxmlformats.org/drawingml/2006/main" xmlns:r="http://schemas.openxmlformats.org/officeDocument/2006/relationships" xmlns:p="http://schemas.openxmlformats.org/presentationml/2006/main">
   <p:cSld>
     <p:spTree>
@@ -17045,7 +17890,7 @@
 </p:sld>
 </file>
 
-<file path=ppt/slides/slide12.xml><?xml version="1.0" encoding="utf-8"?>
+<file path=ppt/slides/slide13.xml><?xml version="1.0" encoding="utf-8"?>
 <p:sld xmlns:a="http://schemas.openxmlformats.org/drawingml/2006/main" xmlns:r="http://schemas.openxmlformats.org/officeDocument/2006/relationships" xmlns:p="http://schemas.openxmlformats.org/presentationml/2006/main">
   <p:cSld>
     <p:bg>
@@ -17648,7 +18493,7 @@
 </p:sld>
 </file>
 
-<file path=ppt/slides/slide13.xml><?xml version="1.0" encoding="utf-8"?>
+<file path=ppt/slides/slide14.xml><?xml version="1.0" encoding="utf-8"?>
 <p:sld xmlns:a="http://schemas.openxmlformats.org/drawingml/2006/main" xmlns:r="http://schemas.openxmlformats.org/officeDocument/2006/relationships" xmlns:p="http://schemas.openxmlformats.org/presentationml/2006/main">
   <p:cSld>
     <p:spTree>
@@ -18222,7 +19067,7 @@
 </p:sld>
 </file>
 
-<file path=ppt/slides/slide14.xml><?xml version="1.0" encoding="utf-8"?>
+<file path=ppt/slides/slide15.xml><?xml version="1.0" encoding="utf-8"?>
 <p:sld xmlns:a="http://schemas.openxmlformats.org/drawingml/2006/main" xmlns:r="http://schemas.openxmlformats.org/officeDocument/2006/relationships" xmlns:p="http://schemas.openxmlformats.org/presentationml/2006/main">
   <p:cSld>
     <p:bg>
@@ -18754,7 +19599,7 @@
 </p:sld>
 </file>
 
-<file path=ppt/slides/slide15.xml><?xml version="1.0" encoding="utf-8"?>
+<file path=ppt/slides/slide16.xml><?xml version="1.0" encoding="utf-8"?>
 <p:sld xmlns:a="http://schemas.openxmlformats.org/drawingml/2006/main" xmlns:r="http://schemas.openxmlformats.org/officeDocument/2006/relationships" xmlns:p="http://schemas.openxmlformats.org/presentationml/2006/main">
   <p:cSld>
     <p:bg>
@@ -19111,7 +19956,7 @@
 </p:sld>
 </file>
 
-<file path=ppt/slides/slide16.xml><?xml version="1.0" encoding="utf-8"?>
+<file path=ppt/slides/slide17.xml><?xml version="1.0" encoding="utf-8"?>
 <p:sld xmlns:a="http://schemas.openxmlformats.org/drawingml/2006/main" xmlns:r="http://schemas.openxmlformats.org/officeDocument/2006/relationships" xmlns:p="http://schemas.openxmlformats.org/presentationml/2006/main">
   <p:cSld>
     <p:bg>
@@ -19716,6 +20561,541 @@
     </p:bg>
     <p:spTree>
       <p:nvGrpSpPr>
+        <p:cNvPr id="1" name="Shape 88">
+          <a:extLst>
+            <a:ext uri="{FF2B5EF4-FFF2-40B4-BE49-F238E27FC236}">
+              <a16:creationId xmlns:a16="http://schemas.microsoft.com/office/drawing/2014/main" id="{8AF3B574-1FB7-47D8-7C3B-2D8B80C1B71E}"/>
+            </a:ext>
+          </a:extLst>
+        </p:cNvPr>
+        <p:cNvGrpSpPr/>
+        <p:nvPr/>
+      </p:nvGrpSpPr>
+      <p:grpSpPr>
+        <a:xfrm>
+          <a:off x="0" y="0"/>
+          <a:ext cx="0" cy="0"/>
+          <a:chOff x="0" y="0"/>
+          <a:chExt cx="0" cy="0"/>
+        </a:xfrm>
+      </p:grpSpPr>
+      <p:grpSp>
+        <p:nvGrpSpPr>
+          <p:cNvPr id="2" name="Group 1">
+            <a:extLst>
+              <a:ext uri="{FF2B5EF4-FFF2-40B4-BE49-F238E27FC236}">
+                <a16:creationId xmlns:a16="http://schemas.microsoft.com/office/drawing/2014/main" id="{018C368B-FE2D-5B17-BE43-7465482AEBFA}"/>
+              </a:ext>
+            </a:extLst>
+          </p:cNvPr>
+          <p:cNvGrpSpPr/>
+          <p:nvPr/>
+        </p:nvGrpSpPr>
+        <p:grpSpPr>
+          <a:xfrm>
+            <a:off x="1441528" y="2296815"/>
+            <a:ext cx="9308941" cy="2264370"/>
+            <a:chOff x="1441528" y="1491040"/>
+            <a:chExt cx="9308941" cy="2264370"/>
+          </a:xfrm>
+        </p:grpSpPr>
+        <p:sp>
+          <p:nvSpPr>
+            <p:cNvPr id="89" name="Google Shape;89;p27">
+              <a:extLst>
+                <a:ext uri="{FF2B5EF4-FFF2-40B4-BE49-F238E27FC236}">
+                  <a16:creationId xmlns:a16="http://schemas.microsoft.com/office/drawing/2014/main" id="{BCBC3FB6-47F6-7775-CB52-E1D0141B8A3F}"/>
+                </a:ext>
+              </a:extLst>
+            </p:cNvPr>
+            <p:cNvSpPr txBox="1"/>
+            <p:nvPr/>
+          </p:nvSpPr>
+          <p:spPr>
+            <a:xfrm>
+              <a:off x="2206906" y="1491040"/>
+              <a:ext cx="7778187" cy="1015663"/>
+            </a:xfrm>
+            <a:prstGeom prst="rect">
+              <a:avLst/>
+            </a:prstGeom>
+            <a:noFill/>
+            <a:ln>
+              <a:noFill/>
+            </a:ln>
+          </p:spPr>
+          <p:txBody>
+            <a:bodyPr spcFirstLastPara="1" wrap="square" lIns="91425" tIns="45700" rIns="91425" bIns="45700" anchor="t" anchorCtr="0">
+              <a:spAutoFit/>
+            </a:bodyPr>
+            <a:lstStyle/>
+            <a:p>
+              <a:pPr marL="0" marR="0" lvl="0" indent="0" algn="ctr" rtl="0">
+                <a:lnSpc>
+                  <a:spcPct val="100000"/>
+                </a:lnSpc>
+                <a:spcBef>
+                  <a:spcPts val="0"/>
+                </a:spcBef>
+                <a:spcAft>
+                  <a:spcPts val="0"/>
+                </a:spcAft>
+                <a:buClr>
+                  <a:srgbClr val="000000"/>
+                </a:buClr>
+                <a:buSzPts val="6000"/>
+                <a:buFont typeface="Arial"/>
+                <a:buNone/>
+              </a:pPr>
+              <a:r>
+                <a:rPr lang="en-US" sz="6000" b="1" i="0" u="none" strike="noStrike" cap="none" dirty="0">
+                  <a:solidFill>
+                    <a:schemeClr val="lt1"/>
+                  </a:solidFill>
+                  <a:latin typeface="Arial"/>
+                  <a:ea typeface="Arial"/>
+                  <a:cs typeface="Arial"/>
+                  <a:sym typeface="Arial"/>
+                </a:rPr>
+                <a:t>Questions?</a:t>
+              </a:r>
+              <a:endParaRPr sz="1400" b="0" i="0" u="none" strike="noStrike" cap="none" dirty="0">
+                <a:solidFill>
+                  <a:srgbClr val="000000"/>
+                </a:solidFill>
+                <a:latin typeface="Arial"/>
+                <a:ea typeface="Arial"/>
+                <a:cs typeface="Arial"/>
+                <a:sym typeface="Arial"/>
+              </a:endParaRPr>
+            </a:p>
+          </p:txBody>
+        </p:sp>
+        <p:sp>
+          <p:nvSpPr>
+            <p:cNvPr id="90" name="Google Shape;90;p27">
+              <a:extLst>
+                <a:ext uri="{FF2B5EF4-FFF2-40B4-BE49-F238E27FC236}">
+                  <a16:creationId xmlns:a16="http://schemas.microsoft.com/office/drawing/2014/main" id="{D56A7593-AC73-7040-DB5D-E69F313BBDE7}"/>
+                </a:ext>
+              </a:extLst>
+            </p:cNvPr>
+            <p:cNvSpPr txBox="1"/>
+            <p:nvPr/>
+          </p:nvSpPr>
+          <p:spPr>
+            <a:xfrm>
+              <a:off x="1441528" y="3232230"/>
+              <a:ext cx="9308941" cy="523180"/>
+            </a:xfrm>
+            <a:prstGeom prst="rect">
+              <a:avLst/>
+            </a:prstGeom>
+            <a:noFill/>
+            <a:ln>
+              <a:noFill/>
+            </a:ln>
+          </p:spPr>
+          <p:txBody>
+            <a:bodyPr spcFirstLastPara="1" wrap="square" lIns="91425" tIns="45700" rIns="91425" bIns="45700" anchor="t" anchorCtr="0">
+              <a:spAutoFit/>
+            </a:bodyPr>
+            <a:lstStyle/>
+            <a:p>
+              <a:pPr marL="0" marR="0" lvl="0" indent="0" algn="ctr" rtl="0">
+                <a:lnSpc>
+                  <a:spcPct val="100000"/>
+                </a:lnSpc>
+                <a:spcBef>
+                  <a:spcPts val="0"/>
+                </a:spcBef>
+                <a:spcAft>
+                  <a:spcPts val="0"/>
+                </a:spcAft>
+                <a:buClr>
+                  <a:srgbClr val="000000"/>
+                </a:buClr>
+                <a:buSzPts val="2800"/>
+                <a:buFont typeface="Arial"/>
+                <a:buNone/>
+              </a:pPr>
+              <a:r>
+                <a:rPr lang="en-US" sz="2800" b="0" i="0" u="none" strike="noStrike" cap="none" dirty="0">
+                  <a:solidFill>
+                    <a:schemeClr val="lt1"/>
+                  </a:solidFill>
+                  <a:latin typeface="Arial"/>
+                  <a:ea typeface="Arial"/>
+                  <a:cs typeface="Arial"/>
+                  <a:sym typeface="Arial"/>
+                </a:rPr>
+                <a:t>Homework, Lab, LabVIEW?</a:t>
+              </a:r>
+              <a:endParaRPr sz="1800" b="0" i="0" u="none" strike="noStrike" cap="none" dirty="0">
+                <a:solidFill>
+                  <a:schemeClr val="lt1"/>
+                </a:solidFill>
+                <a:latin typeface="Arial"/>
+                <a:ea typeface="Arial"/>
+                <a:cs typeface="Arial"/>
+                <a:sym typeface="Arial"/>
+              </a:endParaRPr>
+            </a:p>
+          </p:txBody>
+        </p:sp>
+        <p:cxnSp>
+          <p:nvCxnSpPr>
+            <p:cNvPr id="92" name="Google Shape;92;p27">
+              <a:extLst>
+                <a:ext uri="{FF2B5EF4-FFF2-40B4-BE49-F238E27FC236}">
+                  <a16:creationId xmlns:a16="http://schemas.microsoft.com/office/drawing/2014/main" id="{BFE751B6-CF4D-273E-D560-6B4D883779FC}"/>
+                </a:ext>
+              </a:extLst>
+            </p:cNvPr>
+            <p:cNvCxnSpPr/>
+            <p:nvPr/>
+          </p:nvCxnSpPr>
+          <p:spPr>
+            <a:xfrm>
+              <a:off x="4426226" y="2676939"/>
+              <a:ext cx="3379304" cy="0"/>
+            </a:xfrm>
+            <a:prstGeom prst="straightConnector1">
+              <a:avLst/>
+            </a:prstGeom>
+            <a:noFill/>
+            <a:ln w="19050" cap="flat" cmpd="sng">
+              <a:solidFill>
+                <a:srgbClr val="E84B36"/>
+              </a:solidFill>
+              <a:prstDash val="solid"/>
+              <a:round/>
+              <a:headEnd type="none" w="sm" len="sm"/>
+              <a:tailEnd type="none" w="sm" len="sm"/>
+            </a:ln>
+          </p:spPr>
+        </p:cxnSp>
+        <p:cxnSp>
+          <p:nvCxnSpPr>
+            <p:cNvPr id="93" name="Google Shape;93;p27">
+              <a:extLst>
+                <a:ext uri="{FF2B5EF4-FFF2-40B4-BE49-F238E27FC236}">
+                  <a16:creationId xmlns:a16="http://schemas.microsoft.com/office/drawing/2014/main" id="{A7768501-64BD-D022-44D2-3CA620B502C6}"/>
+                </a:ext>
+              </a:extLst>
+            </p:cNvPr>
+            <p:cNvCxnSpPr/>
+            <p:nvPr/>
+          </p:nvCxnSpPr>
+          <p:spPr>
+            <a:xfrm rot="10800000" flipH="1">
+              <a:off x="3943790" y="2676939"/>
+              <a:ext cx="482436" cy="322845"/>
+            </a:xfrm>
+            <a:prstGeom prst="straightConnector1">
+              <a:avLst/>
+            </a:prstGeom>
+            <a:noFill/>
+            <a:ln w="19050" cap="flat" cmpd="sng">
+              <a:solidFill>
+                <a:srgbClr val="E84B36"/>
+              </a:solidFill>
+              <a:prstDash val="solid"/>
+              <a:round/>
+              <a:headEnd type="none" w="sm" len="sm"/>
+              <a:tailEnd type="none" w="sm" len="sm"/>
+            </a:ln>
+          </p:spPr>
+        </p:cxnSp>
+      </p:grpSp>
+      <p:pic>
+        <p:nvPicPr>
+          <p:cNvPr id="94" name="Google Shape;94;p27">
+            <a:extLst>
+              <a:ext uri="{FF2B5EF4-FFF2-40B4-BE49-F238E27FC236}">
+                <a16:creationId xmlns:a16="http://schemas.microsoft.com/office/drawing/2014/main" id="{19915C55-6271-9B95-62A4-D901C77AA9DE}"/>
+              </a:ext>
+            </a:extLst>
+          </p:cNvPr>
+          <p:cNvPicPr preferRelativeResize="0"/>
+          <p:nvPr/>
+        </p:nvPicPr>
+        <p:blipFill rotWithShape="1">
+          <a:blip r:embed="rId4">
+            <a:alphaModFix/>
+          </a:blip>
+          <a:srcRect/>
+          <a:stretch/>
+        </p:blipFill>
+        <p:spPr>
+          <a:xfrm>
+            <a:off x="11557509" y="233819"/>
+            <a:ext cx="271308" cy="389810"/>
+          </a:xfrm>
+          <a:prstGeom prst="rect">
+            <a:avLst/>
+          </a:prstGeom>
+          <a:noFill/>
+          <a:ln>
+            <a:noFill/>
+          </a:ln>
+        </p:spPr>
+      </p:pic>
+      <p:sp>
+        <p:nvSpPr>
+          <p:cNvPr id="95" name="Google Shape;95;p27">
+            <a:extLst>
+              <a:ext uri="{FF2B5EF4-FFF2-40B4-BE49-F238E27FC236}">
+                <a16:creationId xmlns:a16="http://schemas.microsoft.com/office/drawing/2014/main" id="{96534BB9-415B-75C5-14DF-605417B1EA0F}"/>
+              </a:ext>
+            </a:extLst>
+          </p:cNvPr>
+          <p:cNvSpPr txBox="1"/>
+          <p:nvPr/>
+        </p:nvSpPr>
+        <p:spPr>
+          <a:xfrm>
+            <a:off x="9335597" y="6524381"/>
+            <a:ext cx="2473415" cy="230792"/>
+          </a:xfrm>
+          <a:prstGeom prst="rect">
+            <a:avLst/>
+          </a:prstGeom>
+          <a:noFill/>
+          <a:ln>
+            <a:noFill/>
+          </a:ln>
+        </p:spPr>
+        <p:txBody>
+          <a:bodyPr spcFirstLastPara="1" wrap="square" lIns="91425" tIns="45700" rIns="91425" bIns="45700" anchor="t" anchorCtr="0">
+            <a:spAutoFit/>
+          </a:bodyPr>
+          <a:lstStyle/>
+          <a:p>
+            <a:pPr marL="0" marR="0" lvl="0" indent="0" algn="r" rtl="0">
+              <a:lnSpc>
+                <a:spcPct val="100000"/>
+              </a:lnSpc>
+              <a:spcBef>
+                <a:spcPts val="0"/>
+              </a:spcBef>
+              <a:spcAft>
+                <a:spcPts val="0"/>
+              </a:spcAft>
+              <a:buNone/>
+            </a:pPr>
+            <a:r>
+              <a:rPr lang="en-US" sz="900" b="0" i="0" u="none" strike="noStrike" cap="none">
+                <a:solidFill>
+                  <a:schemeClr val="lt1"/>
+                </a:solidFill>
+                <a:latin typeface="Arial"/>
+                <a:ea typeface="Arial"/>
+                <a:cs typeface="Arial"/>
+                <a:sym typeface="Arial"/>
+              </a:rPr>
+              <a:t>GRAINGER ENGINEERING</a:t>
+            </a:r>
+            <a:endParaRPr/>
+          </a:p>
+        </p:txBody>
+      </p:sp>
+      <p:sp>
+        <p:nvSpPr>
+          <p:cNvPr id="96" name="Google Shape;96;p27">
+            <a:extLst>
+              <a:ext uri="{FF2B5EF4-FFF2-40B4-BE49-F238E27FC236}">
+                <a16:creationId xmlns:a16="http://schemas.microsoft.com/office/drawing/2014/main" id="{A8493C96-336F-E402-218B-5C13C8F047B5}"/>
+              </a:ext>
+            </a:extLst>
+          </p:cNvPr>
+          <p:cNvSpPr txBox="1"/>
+          <p:nvPr/>
+        </p:nvSpPr>
+        <p:spPr>
+          <a:xfrm>
+            <a:off x="376807" y="6524381"/>
+            <a:ext cx="7991337" cy="230792"/>
+          </a:xfrm>
+          <a:prstGeom prst="rect">
+            <a:avLst/>
+          </a:prstGeom>
+          <a:noFill/>
+          <a:ln>
+            <a:noFill/>
+          </a:ln>
+        </p:spPr>
+        <p:txBody>
+          <a:bodyPr spcFirstLastPara="1" wrap="square" lIns="91425" tIns="45700" rIns="91425" bIns="45700" anchor="t" anchorCtr="0">
+            <a:spAutoFit/>
+          </a:bodyPr>
+          <a:lstStyle/>
+          <a:p>
+            <a:pPr marL="0" marR="0" lvl="0" indent="0" algn="l" rtl="0">
+              <a:lnSpc>
+                <a:spcPct val="100000"/>
+              </a:lnSpc>
+              <a:spcBef>
+                <a:spcPts val="0"/>
+              </a:spcBef>
+              <a:spcAft>
+                <a:spcPts val="0"/>
+              </a:spcAft>
+              <a:buNone/>
+            </a:pPr>
+            <a:r>
+              <a:rPr lang="en-US" sz="900" dirty="0">
+                <a:solidFill>
+                  <a:schemeClr val="lt1"/>
+                </a:solidFill>
+              </a:rPr>
+              <a:t>SYSTEMS ENGINEERING </a:t>
+            </a:r>
+            <a:endParaRPr dirty="0"/>
+          </a:p>
+        </p:txBody>
+      </p:sp>
+      <p:grpSp>
+        <p:nvGrpSpPr>
+          <p:cNvPr id="97" name="Google Shape;97;p27">
+            <a:extLst>
+              <a:ext uri="{FF2B5EF4-FFF2-40B4-BE49-F238E27FC236}">
+                <a16:creationId xmlns:a16="http://schemas.microsoft.com/office/drawing/2014/main" id="{33C3076B-D3BE-042B-369B-996B00F03F2C}"/>
+              </a:ext>
+            </a:extLst>
+          </p:cNvPr>
+          <p:cNvGrpSpPr/>
+          <p:nvPr/>
+        </p:nvGrpSpPr>
+        <p:grpSpPr>
+          <a:xfrm>
+            <a:off x="4066674" y="6601537"/>
+            <a:ext cx="5233412" cy="70446"/>
+            <a:chOff x="4033424" y="6601537"/>
+            <a:chExt cx="5233412" cy="70446"/>
+          </a:xfrm>
+        </p:grpSpPr>
+        <p:cxnSp>
+          <p:nvCxnSpPr>
+            <p:cNvPr id="98" name="Google Shape;98;p27">
+              <a:extLst>
+                <a:ext uri="{FF2B5EF4-FFF2-40B4-BE49-F238E27FC236}">
+                  <a16:creationId xmlns:a16="http://schemas.microsoft.com/office/drawing/2014/main" id="{A886A22C-18CA-ADCE-8A13-5D51F5F174D3}"/>
+                </a:ext>
+              </a:extLst>
+            </p:cNvPr>
+            <p:cNvCxnSpPr/>
+            <p:nvPr/>
+          </p:nvCxnSpPr>
+          <p:spPr>
+            <a:xfrm rot="10800000">
+              <a:off x="4033424" y="6639606"/>
+              <a:ext cx="5164651" cy="0"/>
+            </a:xfrm>
+            <a:prstGeom prst="straightConnector1">
+              <a:avLst/>
+            </a:prstGeom>
+            <a:noFill/>
+            <a:ln w="9525" cap="flat" cmpd="sng">
+              <a:solidFill>
+                <a:schemeClr val="lt1"/>
+              </a:solidFill>
+              <a:prstDash val="solid"/>
+              <a:round/>
+              <a:headEnd type="none" w="sm" len="sm"/>
+              <a:tailEnd type="none" w="sm" len="sm"/>
+            </a:ln>
+          </p:spPr>
+        </p:cxnSp>
+        <p:sp>
+          <p:nvSpPr>
+            <p:cNvPr id="99" name="Google Shape;99;p27">
+              <a:extLst>
+                <a:ext uri="{FF2B5EF4-FFF2-40B4-BE49-F238E27FC236}">
+                  <a16:creationId xmlns:a16="http://schemas.microsoft.com/office/drawing/2014/main" id="{F5546652-0DF2-2B1B-5CB6-25C023D4F23A}"/>
+                </a:ext>
+              </a:extLst>
+            </p:cNvPr>
+            <p:cNvSpPr/>
+            <p:nvPr/>
+          </p:nvSpPr>
+          <p:spPr>
+            <a:xfrm>
+              <a:off x="9196390" y="6601537"/>
+              <a:ext cx="70446" cy="70446"/>
+            </a:xfrm>
+            <a:prstGeom prst="ellipse">
+              <a:avLst/>
+            </a:prstGeom>
+            <a:solidFill>
+              <a:schemeClr val="lt1"/>
+            </a:solidFill>
+            <a:ln>
+              <a:noFill/>
+            </a:ln>
+          </p:spPr>
+          <p:txBody>
+            <a:bodyPr spcFirstLastPara="1" wrap="square" lIns="91425" tIns="45700" rIns="91425" bIns="45700" anchor="ctr" anchorCtr="0">
+              <a:noAutofit/>
+            </a:bodyPr>
+            <a:lstStyle/>
+            <a:p>
+              <a:pPr marL="0" marR="0" lvl="0" indent="0" algn="ctr" rtl="0">
+                <a:lnSpc>
+                  <a:spcPct val="100000"/>
+                </a:lnSpc>
+                <a:spcBef>
+                  <a:spcPts val="0"/>
+                </a:spcBef>
+                <a:spcAft>
+                  <a:spcPts val="0"/>
+                </a:spcAft>
+                <a:buNone/>
+              </a:pPr>
+              <a:endParaRPr sz="1400" b="0" i="0" u="none" strike="noStrike" cap="none">
+                <a:solidFill>
+                  <a:schemeClr val="lt1"/>
+                </a:solidFill>
+                <a:latin typeface="Arial"/>
+                <a:ea typeface="Arial"/>
+                <a:cs typeface="Arial"/>
+                <a:sym typeface="Arial"/>
+              </a:endParaRPr>
+            </a:p>
+          </p:txBody>
+        </p:sp>
+      </p:grpSp>
+    </p:spTree>
+    <p:extLst>
+      <p:ext uri="{BB962C8B-B14F-4D97-AF65-F5344CB8AC3E}">
+        <p14:creationId xmlns:p14="http://schemas.microsoft.com/office/powerpoint/2010/main" val="2130656613"/>
+      </p:ext>
+    </p:extLst>
+  </p:cSld>
+  <p:clrMapOvr>
+    <a:masterClrMapping/>
+  </p:clrMapOvr>
+</p:sld>
+</file>
+
+<file path=ppt/slides/slide4.xml><?xml version="1.0" encoding="utf-8"?>
+<p:sld xmlns:a="http://schemas.openxmlformats.org/drawingml/2006/main" xmlns:r="http://schemas.openxmlformats.org/officeDocument/2006/relationships" xmlns:p="http://schemas.openxmlformats.org/presentationml/2006/main">
+  <p:cSld>
+    <p:bg>
+      <p:bgPr>
+        <a:blipFill>
+          <a:blip r:embed="rId3">
+            <a:alphaModFix/>
+          </a:blip>
+          <a:stretch>
+            <a:fillRect/>
+          </a:stretch>
+        </a:blipFill>
+        <a:effectLst/>
+      </p:bgPr>
+    </p:bg>
+    <p:spTree>
+      <p:nvGrpSpPr>
         <p:cNvPr id="1" name="Shape 103"/>
         <p:cNvGrpSpPr/>
         <p:nvPr/>
@@ -20145,7 +21525,7 @@
 </p:sld>
 </file>
 
-<file path=ppt/slides/slide4.xml><?xml version="1.0" encoding="utf-8"?>
+<file path=ppt/slides/slide5.xml><?xml version="1.0" encoding="utf-8"?>
 <p:sld xmlns:a="http://schemas.openxmlformats.org/drawingml/2006/main" xmlns:r="http://schemas.openxmlformats.org/officeDocument/2006/relationships" xmlns:p="http://schemas.openxmlformats.org/presentationml/2006/main">
   <p:cSld>
     <p:spTree>
@@ -20745,7 +22125,7 @@
 </p:sld>
 </file>
 
-<file path=ppt/slides/slide5.xml><?xml version="1.0" encoding="utf-8"?>
+<file path=ppt/slides/slide6.xml><?xml version="1.0" encoding="utf-8"?>
 <p:sld xmlns:a="http://schemas.openxmlformats.org/drawingml/2006/main" xmlns:r="http://schemas.openxmlformats.org/officeDocument/2006/relationships" xmlns:p="http://schemas.openxmlformats.org/presentationml/2006/main">
   <p:cSld>
     <p:spTree>
@@ -21351,7 +22731,7 @@
 </p:sld>
 </file>
 
-<file path=ppt/slides/slide6.xml><?xml version="1.0" encoding="utf-8"?>
+<file path=ppt/slides/slide7.xml><?xml version="1.0" encoding="utf-8"?>
 <p:sld xmlns:a="http://schemas.openxmlformats.org/drawingml/2006/main" xmlns:r="http://schemas.openxmlformats.org/officeDocument/2006/relationships" xmlns:p="http://schemas.openxmlformats.org/presentationml/2006/main">
   <p:cSld>
     <p:spTree>
@@ -22190,7 +23570,7 @@
 </p:sld>
 </file>
 
-<file path=ppt/slides/slide7.xml><?xml version="1.0" encoding="utf-8"?>
+<file path=ppt/slides/slide8.xml><?xml version="1.0" encoding="utf-8"?>
 <p:sld xmlns:a="http://schemas.openxmlformats.org/drawingml/2006/main" xmlns:r="http://schemas.openxmlformats.org/officeDocument/2006/relationships" xmlns:p="http://schemas.openxmlformats.org/presentationml/2006/main">
   <p:cSld>
     <p:spTree>
@@ -23030,7 +24410,7 @@
 </p:sld>
 </file>
 
-<file path=ppt/slides/slide8.xml><?xml version="1.0" encoding="utf-8"?>
+<file path=ppt/slides/slide9.xml><?xml version="1.0" encoding="utf-8"?>
 <p:sld xmlns:a="http://schemas.openxmlformats.org/drawingml/2006/main" xmlns:r="http://schemas.openxmlformats.org/officeDocument/2006/relationships" xmlns:p="http://schemas.openxmlformats.org/presentationml/2006/main">
   <p:cSld>
     <p:spTree>
@@ -23690,723 +25070,6 @@
         <p:sp>
           <p:nvSpPr>
             <p:cNvPr id="189" name="Google Shape;189;p32"/>
-            <p:cNvSpPr/>
-            <p:nvPr/>
-          </p:nvSpPr>
-          <p:spPr>
-            <a:xfrm>
-              <a:off x="9196390" y="6601537"/>
-              <a:ext cx="70446" cy="70446"/>
-            </a:xfrm>
-            <a:prstGeom prst="ellipse">
-              <a:avLst/>
-            </a:prstGeom>
-            <a:solidFill>
-              <a:srgbClr val="13294B"/>
-            </a:solidFill>
-            <a:ln>
-              <a:noFill/>
-            </a:ln>
-          </p:spPr>
-          <p:txBody>
-            <a:bodyPr spcFirstLastPara="1" wrap="square" lIns="91425" tIns="45700" rIns="91425" bIns="45700" anchor="ctr" anchorCtr="0">
-              <a:noAutofit/>
-            </a:bodyPr>
-            <a:lstStyle/>
-            <a:p>
-              <a:pPr marL="0" marR="0" lvl="0" indent="0" algn="ctr" rtl="0">
-                <a:lnSpc>
-                  <a:spcPct val="100000"/>
-                </a:lnSpc>
-                <a:spcBef>
-                  <a:spcPts val="0"/>
-                </a:spcBef>
-                <a:spcAft>
-                  <a:spcPts val="0"/>
-                </a:spcAft>
-                <a:buNone/>
-              </a:pPr>
-              <a:endParaRPr sz="1400" b="0" i="0" u="none" strike="noStrike" cap="none">
-                <a:solidFill>
-                  <a:srgbClr val="13294B"/>
-                </a:solidFill>
-                <a:latin typeface="Arial"/>
-                <a:ea typeface="Arial"/>
-                <a:cs typeface="Arial"/>
-                <a:sym typeface="Arial"/>
-              </a:endParaRPr>
-            </a:p>
-          </p:txBody>
-        </p:sp>
-      </p:grpSp>
-    </p:spTree>
-  </p:cSld>
-  <p:clrMapOvr>
-    <a:masterClrMapping/>
-  </p:clrMapOvr>
-</p:sld>
-</file>
-
-<file path=ppt/slides/slide9.xml><?xml version="1.0" encoding="utf-8"?>
-<p:sld xmlns:a="http://schemas.openxmlformats.org/drawingml/2006/main" xmlns:r="http://schemas.openxmlformats.org/officeDocument/2006/relationships" xmlns:p="http://schemas.openxmlformats.org/presentationml/2006/main">
-  <p:cSld>
-    <p:spTree>
-      <p:nvGrpSpPr>
-        <p:cNvPr id="1" name="Shape 193"/>
-        <p:cNvGrpSpPr/>
-        <p:nvPr/>
-      </p:nvGrpSpPr>
-      <p:grpSpPr>
-        <a:xfrm>
-          <a:off x="0" y="0"/>
-          <a:ext cx="0" cy="0"/>
-          <a:chOff x="0" y="0"/>
-          <a:chExt cx="0" cy="0"/>
-        </a:xfrm>
-      </p:grpSpPr>
-      <p:sp>
-        <p:nvSpPr>
-          <p:cNvPr id="194" name="Google Shape;194;p33"/>
-          <p:cNvSpPr/>
-          <p:nvPr/>
-        </p:nvSpPr>
-        <p:spPr>
-          <a:xfrm>
-            <a:off x="7452352" y="1263718"/>
-            <a:ext cx="4356660" cy="4825998"/>
-          </a:xfrm>
-          <a:prstGeom prst="rect">
-            <a:avLst/>
-          </a:prstGeom>
-          <a:solidFill>
-            <a:srgbClr val="D8D8D8"/>
-          </a:solidFill>
-          <a:ln>
-            <a:noFill/>
-          </a:ln>
-        </p:spPr>
-        <p:txBody>
-          <a:bodyPr spcFirstLastPara="1" wrap="square" lIns="91425" tIns="45700" rIns="91425" bIns="45700" anchor="ctr" anchorCtr="0">
-            <a:noAutofit/>
-          </a:bodyPr>
-          <a:lstStyle/>
-          <a:p>
-            <a:pPr marL="0" marR="0" lvl="0" indent="0" algn="ctr" rtl="0">
-              <a:lnSpc>
-                <a:spcPct val="100000"/>
-              </a:lnSpc>
-              <a:spcBef>
-                <a:spcPts val="0"/>
-              </a:spcBef>
-              <a:spcAft>
-                <a:spcPts val="0"/>
-              </a:spcAft>
-              <a:buClr>
-                <a:srgbClr val="000000"/>
-              </a:buClr>
-              <a:buSzPts val="1800"/>
-              <a:buFont typeface="Arial"/>
-              <a:buNone/>
-            </a:pPr>
-            <a:endParaRPr sz="1800" b="0" i="0" u="none" strike="noStrike" cap="none">
-              <a:solidFill>
-                <a:schemeClr val="lt1"/>
-              </a:solidFill>
-              <a:latin typeface="Calibri"/>
-              <a:ea typeface="Calibri"/>
-              <a:cs typeface="Calibri"/>
-              <a:sym typeface="Calibri"/>
-            </a:endParaRPr>
-          </a:p>
-        </p:txBody>
-      </p:sp>
-      <p:sp>
-        <p:nvSpPr>
-          <p:cNvPr id="195" name="Google Shape;195;p33"/>
-          <p:cNvSpPr txBox="1"/>
-          <p:nvPr/>
-        </p:nvSpPr>
-        <p:spPr>
-          <a:xfrm>
-            <a:off x="8490436" y="3493224"/>
-            <a:ext cx="2280491" cy="369332"/>
-          </a:xfrm>
-          <a:prstGeom prst="rect">
-            <a:avLst/>
-          </a:prstGeom>
-          <a:noFill/>
-          <a:ln>
-            <a:noFill/>
-          </a:ln>
-        </p:spPr>
-        <p:txBody>
-          <a:bodyPr spcFirstLastPara="1" wrap="square" lIns="91425" tIns="45700" rIns="91425" bIns="45700" anchor="t" anchorCtr="0">
-            <a:spAutoFit/>
-          </a:bodyPr>
-          <a:lstStyle/>
-          <a:p>
-            <a:pPr marL="0" marR="0" lvl="0" indent="0" algn="ctr" rtl="0">
-              <a:lnSpc>
-                <a:spcPct val="100000"/>
-              </a:lnSpc>
-              <a:spcBef>
-                <a:spcPts val="0"/>
-              </a:spcBef>
-              <a:spcAft>
-                <a:spcPts val="0"/>
-              </a:spcAft>
-              <a:buClr>
-                <a:srgbClr val="000000"/>
-              </a:buClr>
-              <a:buSzPts val="1800"/>
-              <a:buFont typeface="Arial"/>
-              <a:buNone/>
-            </a:pPr>
-            <a:r>
-              <a:rPr lang="en-US" sz="1800" b="0" i="0" u="none" strike="noStrike" cap="none">
-                <a:solidFill>
-                  <a:srgbClr val="A5A5A5"/>
-                </a:solidFill>
-                <a:latin typeface="Arial"/>
-                <a:ea typeface="Arial"/>
-                <a:cs typeface="Arial"/>
-                <a:sym typeface="Arial"/>
-              </a:rPr>
-              <a:t>IMAGE / GRAPHIC</a:t>
-            </a:r>
-            <a:endParaRPr sz="1400" b="0" i="0" u="none" strike="noStrike" cap="none">
-              <a:solidFill>
-                <a:srgbClr val="000000"/>
-              </a:solidFill>
-              <a:latin typeface="Arial"/>
-              <a:ea typeface="Arial"/>
-              <a:cs typeface="Arial"/>
-              <a:sym typeface="Arial"/>
-            </a:endParaRPr>
-          </a:p>
-        </p:txBody>
-      </p:sp>
-      <p:sp>
-        <p:nvSpPr>
-          <p:cNvPr id="196" name="Google Shape;196;p33"/>
-          <p:cNvSpPr txBox="1"/>
-          <p:nvPr/>
-        </p:nvSpPr>
-        <p:spPr>
-          <a:xfrm>
-            <a:off x="376808" y="1334279"/>
-            <a:ext cx="6422373" cy="4821102"/>
-          </a:xfrm>
-          <a:prstGeom prst="rect">
-            <a:avLst/>
-          </a:prstGeom>
-          <a:noFill/>
-          <a:ln>
-            <a:noFill/>
-          </a:ln>
-        </p:spPr>
-        <p:txBody>
-          <a:bodyPr spcFirstLastPara="1" wrap="square" lIns="91425" tIns="45700" rIns="91425" bIns="45700" anchor="t" anchorCtr="0">
-            <a:noAutofit/>
-          </a:bodyPr>
-          <a:lstStyle/>
-          <a:p>
-            <a:pPr marL="0" marR="0" lvl="0" indent="0" algn="l" rtl="0">
-              <a:lnSpc>
-                <a:spcPct val="100000"/>
-              </a:lnSpc>
-              <a:spcBef>
-                <a:spcPts val="0"/>
-              </a:spcBef>
-              <a:spcAft>
-                <a:spcPts val="0"/>
-              </a:spcAft>
-              <a:buNone/>
-            </a:pPr>
-            <a:r>
-              <a:rPr lang="en-US" sz="2600" b="1" i="0" u="none" strike="noStrike" cap="none">
-                <a:solidFill>
-                  <a:srgbClr val="E84B36"/>
-                </a:solidFill>
-                <a:latin typeface="Arial"/>
-                <a:ea typeface="Arial"/>
-                <a:cs typeface="Arial"/>
-                <a:sym typeface="Arial"/>
-              </a:rPr>
-              <a:t>Lorem Ipsum Dolor Sit Amet Consectetur Adipiscing</a:t>
-            </a:r>
-            <a:endParaRPr sz="2600" b="1" i="0" u="none" strike="noStrike" cap="none">
-              <a:solidFill>
-                <a:srgbClr val="E84B36"/>
-              </a:solidFill>
-              <a:latin typeface="Arial"/>
-              <a:ea typeface="Arial"/>
-              <a:cs typeface="Arial"/>
-              <a:sym typeface="Arial"/>
-            </a:endParaRPr>
-          </a:p>
-          <a:p>
-            <a:pPr marL="0" marR="0" lvl="0" indent="0" algn="l" rtl="0">
-              <a:lnSpc>
-                <a:spcPct val="100000"/>
-              </a:lnSpc>
-              <a:spcBef>
-                <a:spcPts val="0"/>
-              </a:spcBef>
-              <a:spcAft>
-                <a:spcPts val="0"/>
-              </a:spcAft>
-              <a:buNone/>
-            </a:pPr>
-            <a:endParaRPr sz="1800" b="0" i="0" u="none" strike="noStrike" cap="none">
-              <a:solidFill>
-                <a:schemeClr val="dk1"/>
-              </a:solidFill>
-              <a:latin typeface="Arial"/>
-              <a:ea typeface="Arial"/>
-              <a:cs typeface="Arial"/>
-              <a:sym typeface="Arial"/>
-            </a:endParaRPr>
-          </a:p>
-          <a:p>
-            <a:pPr marL="0" marR="0" lvl="0" indent="0" algn="l" rtl="0">
-              <a:lnSpc>
-                <a:spcPct val="100000"/>
-              </a:lnSpc>
-              <a:spcBef>
-                <a:spcPts val="0"/>
-              </a:spcBef>
-              <a:spcAft>
-                <a:spcPts val="0"/>
-              </a:spcAft>
-              <a:buNone/>
-            </a:pPr>
-            <a:r>
-              <a:rPr lang="en-US" sz="1800" b="0" i="0" u="none" strike="noStrike" cap="none">
-                <a:solidFill>
-                  <a:srgbClr val="000000"/>
-                </a:solidFill>
-                <a:latin typeface="Arial"/>
-                <a:ea typeface="Arial"/>
-                <a:cs typeface="Arial"/>
-                <a:sym typeface="Arial"/>
-              </a:rPr>
-              <a:t>Lorem ipsum dolor sit amet, consectetur adipiscing elit, sed do eiusmod tempor incididunt ut labore et dolore magna aliqua. Ut enim ad minim veniam, quis nostrud exercitation ullamco laboris nisi ut aliquip ex ea commodo consequat. </a:t>
-            </a:r>
-            <a:endParaRPr/>
-          </a:p>
-          <a:p>
-            <a:pPr marL="0" marR="0" lvl="0" indent="0" algn="l" rtl="0">
-              <a:lnSpc>
-                <a:spcPct val="100000"/>
-              </a:lnSpc>
-              <a:spcBef>
-                <a:spcPts val="0"/>
-              </a:spcBef>
-              <a:spcAft>
-                <a:spcPts val="0"/>
-              </a:spcAft>
-              <a:buNone/>
-            </a:pPr>
-            <a:endParaRPr sz="1800" b="0" i="0" u="none" strike="noStrike" cap="none">
-              <a:solidFill>
-                <a:schemeClr val="dk1"/>
-              </a:solidFill>
-              <a:latin typeface="Arial"/>
-              <a:ea typeface="Arial"/>
-              <a:cs typeface="Arial"/>
-              <a:sym typeface="Arial"/>
-            </a:endParaRPr>
-          </a:p>
-          <a:p>
-            <a:pPr marL="0" marR="0" lvl="0" indent="0" algn="l" rtl="0">
-              <a:lnSpc>
-                <a:spcPct val="100000"/>
-              </a:lnSpc>
-              <a:spcBef>
-                <a:spcPts val="0"/>
-              </a:spcBef>
-              <a:spcAft>
-                <a:spcPts val="0"/>
-              </a:spcAft>
-              <a:buNone/>
-            </a:pPr>
-            <a:r>
-              <a:rPr lang="en-US" sz="2000" b="1" i="0" u="none" strike="noStrike" cap="none">
-                <a:solidFill>
-                  <a:srgbClr val="15264B"/>
-                </a:solidFill>
-                <a:latin typeface="Arial"/>
-                <a:ea typeface="Arial"/>
-                <a:cs typeface="Arial"/>
-                <a:sym typeface="Arial"/>
-              </a:rPr>
-              <a:t>Lorem Ipsum Dolor Sit Amet Consectetur Adipiscing</a:t>
-            </a:r>
-            <a:endParaRPr sz="2000" b="1" i="0" u="none" strike="noStrike" cap="none">
-              <a:solidFill>
-                <a:srgbClr val="15264B"/>
-              </a:solidFill>
-              <a:latin typeface="Arial"/>
-              <a:ea typeface="Arial"/>
-              <a:cs typeface="Arial"/>
-              <a:sym typeface="Arial"/>
-            </a:endParaRPr>
-          </a:p>
-          <a:p>
-            <a:pPr marL="0" marR="0" lvl="0" indent="0" algn="l" rtl="0">
-              <a:lnSpc>
-                <a:spcPct val="100000"/>
-              </a:lnSpc>
-              <a:spcBef>
-                <a:spcPts val="0"/>
-              </a:spcBef>
-              <a:spcAft>
-                <a:spcPts val="0"/>
-              </a:spcAft>
-              <a:buNone/>
-            </a:pPr>
-            <a:endParaRPr sz="1800" b="1" i="0" u="none" strike="noStrike" cap="none">
-              <a:solidFill>
-                <a:schemeClr val="dk1"/>
-              </a:solidFill>
-              <a:latin typeface="Arial"/>
-              <a:ea typeface="Arial"/>
-              <a:cs typeface="Arial"/>
-              <a:sym typeface="Arial"/>
-            </a:endParaRPr>
-          </a:p>
-          <a:p>
-            <a:pPr marL="0" marR="0" lvl="0" indent="0" algn="l" rtl="0">
-              <a:lnSpc>
-                <a:spcPct val="100000"/>
-              </a:lnSpc>
-              <a:spcBef>
-                <a:spcPts val="0"/>
-              </a:spcBef>
-              <a:spcAft>
-                <a:spcPts val="0"/>
-              </a:spcAft>
-              <a:buNone/>
-            </a:pPr>
-            <a:r>
-              <a:rPr lang="en-US" sz="1800" b="0" i="0" u="none" strike="noStrike" cap="none">
-                <a:solidFill>
-                  <a:srgbClr val="000000"/>
-                </a:solidFill>
-                <a:latin typeface="Arial"/>
-                <a:ea typeface="Arial"/>
-                <a:cs typeface="Arial"/>
-                <a:sym typeface="Arial"/>
-              </a:rPr>
-              <a:t>Lorem ipsum dolor sit amet, consectetur adipiscing elit, sed do eiusmod tempor incididunt ut labore et dolore magna aliqua.</a:t>
-            </a:r>
-            <a:endParaRPr sz="1800" b="1" i="0" u="none" strike="noStrike" cap="none">
-              <a:solidFill>
-                <a:schemeClr val="dk1"/>
-              </a:solidFill>
-              <a:latin typeface="Arial"/>
-              <a:ea typeface="Arial"/>
-              <a:cs typeface="Arial"/>
-              <a:sym typeface="Arial"/>
-            </a:endParaRPr>
-          </a:p>
-        </p:txBody>
-      </p:sp>
-      <p:sp>
-        <p:nvSpPr>
-          <p:cNvPr id="197" name="Google Shape;197;p33"/>
-          <p:cNvSpPr/>
-          <p:nvPr/>
-        </p:nvSpPr>
-        <p:spPr>
-          <a:xfrm rot="10800000" flipH="1">
-            <a:off x="0" y="0"/>
-            <a:ext cx="12192000" cy="868220"/>
-          </a:xfrm>
-          <a:prstGeom prst="rect">
-            <a:avLst/>
-          </a:prstGeom>
-          <a:solidFill>
-            <a:srgbClr val="13294B"/>
-          </a:solidFill>
-          <a:ln>
-            <a:noFill/>
-          </a:ln>
-        </p:spPr>
-        <p:txBody>
-          <a:bodyPr spcFirstLastPara="1" wrap="square" lIns="91425" tIns="45700" rIns="91425" bIns="45700" anchor="ctr" anchorCtr="0">
-            <a:noAutofit/>
-          </a:bodyPr>
-          <a:lstStyle/>
-          <a:p>
-            <a:pPr marL="0" marR="0" lvl="0" indent="0" algn="ctr" rtl="0">
-              <a:lnSpc>
-                <a:spcPct val="100000"/>
-              </a:lnSpc>
-              <a:spcBef>
-                <a:spcPts val="0"/>
-              </a:spcBef>
-              <a:spcAft>
-                <a:spcPts val="0"/>
-              </a:spcAft>
-              <a:buClr>
-                <a:schemeClr val="lt1"/>
-              </a:buClr>
-              <a:buSzPts val="1800"/>
-              <a:buFont typeface="Calibri"/>
-              <a:buNone/>
-            </a:pPr>
-            <a:endParaRPr sz="1800" b="0" i="0" u="none" strike="noStrike" cap="none">
-              <a:solidFill>
-                <a:srgbClr val="13294B"/>
-              </a:solidFill>
-              <a:latin typeface="Calibri"/>
-              <a:ea typeface="Calibri"/>
-              <a:cs typeface="Calibri"/>
-              <a:sym typeface="Calibri"/>
-            </a:endParaRPr>
-          </a:p>
-        </p:txBody>
-      </p:sp>
-      <p:sp>
-        <p:nvSpPr>
-          <p:cNvPr id="198" name="Google Shape;198;p33"/>
-          <p:cNvSpPr txBox="1"/>
-          <p:nvPr/>
-        </p:nvSpPr>
-        <p:spPr>
-          <a:xfrm>
-            <a:off x="376810" y="204051"/>
-            <a:ext cx="10910026" cy="461624"/>
-          </a:xfrm>
-          <a:prstGeom prst="rect">
-            <a:avLst/>
-          </a:prstGeom>
-          <a:noFill/>
-          <a:ln>
-            <a:noFill/>
-          </a:ln>
-        </p:spPr>
-        <p:txBody>
-          <a:bodyPr spcFirstLastPara="1" wrap="square" lIns="91425" tIns="45700" rIns="91425" bIns="45700" anchor="t" anchorCtr="0">
-            <a:spAutoFit/>
-          </a:bodyPr>
-          <a:lstStyle/>
-          <a:p>
-            <a:pPr marL="0" marR="0" lvl="0" indent="0" algn="l" rtl="0">
-              <a:lnSpc>
-                <a:spcPct val="100000"/>
-              </a:lnSpc>
-              <a:spcBef>
-                <a:spcPts val="0"/>
-              </a:spcBef>
-              <a:spcAft>
-                <a:spcPts val="0"/>
-              </a:spcAft>
-              <a:buClr>
-                <a:srgbClr val="000000"/>
-              </a:buClr>
-              <a:buSzPts val="2400"/>
-              <a:buFont typeface="Arial"/>
-              <a:buNone/>
-            </a:pPr>
-            <a:r>
-              <a:rPr lang="en-US" sz="2400" b="0" i="0" u="none" strike="noStrike" cap="none">
-                <a:solidFill>
-                  <a:schemeClr val="lt1"/>
-                </a:solidFill>
-                <a:latin typeface="Arial"/>
-                <a:ea typeface="Arial"/>
-                <a:cs typeface="Arial"/>
-                <a:sym typeface="Arial"/>
-              </a:rPr>
-              <a:t>Slide Title</a:t>
-            </a:r>
-            <a:endParaRPr sz="2400" b="0" i="0" u="none" strike="noStrike" cap="none">
-              <a:solidFill>
-                <a:schemeClr val="lt1"/>
-              </a:solidFill>
-              <a:latin typeface="Arial"/>
-              <a:ea typeface="Arial"/>
-              <a:cs typeface="Arial"/>
-              <a:sym typeface="Arial"/>
-            </a:endParaRPr>
-          </a:p>
-        </p:txBody>
-      </p:sp>
-      <p:pic>
-        <p:nvPicPr>
-          <p:cNvPr id="199" name="Google Shape;199;p33"/>
-          <p:cNvPicPr preferRelativeResize="0"/>
-          <p:nvPr/>
-        </p:nvPicPr>
-        <p:blipFill rotWithShape="1">
-          <a:blip r:embed="rId3">
-            <a:alphaModFix/>
-          </a:blip>
-          <a:srcRect/>
-          <a:stretch/>
-        </p:blipFill>
-        <p:spPr>
-          <a:xfrm>
-            <a:off x="11557509" y="233819"/>
-            <a:ext cx="271308" cy="389810"/>
-          </a:xfrm>
-          <a:prstGeom prst="rect">
-            <a:avLst/>
-          </a:prstGeom>
-          <a:noFill/>
-          <a:ln>
-            <a:noFill/>
-          </a:ln>
-        </p:spPr>
-      </p:pic>
-      <p:sp>
-        <p:nvSpPr>
-          <p:cNvPr id="200" name="Google Shape;200;p33"/>
-          <p:cNvSpPr txBox="1"/>
-          <p:nvPr/>
-        </p:nvSpPr>
-        <p:spPr>
-          <a:xfrm>
-            <a:off x="9335597" y="6524381"/>
-            <a:ext cx="2473415" cy="230792"/>
-          </a:xfrm>
-          <a:prstGeom prst="rect">
-            <a:avLst/>
-          </a:prstGeom>
-          <a:noFill/>
-          <a:ln>
-            <a:noFill/>
-          </a:ln>
-        </p:spPr>
-        <p:txBody>
-          <a:bodyPr spcFirstLastPara="1" wrap="square" lIns="91425" tIns="45700" rIns="91425" bIns="45700" anchor="t" anchorCtr="0">
-            <a:spAutoFit/>
-          </a:bodyPr>
-          <a:lstStyle/>
-          <a:p>
-            <a:pPr marL="0" marR="0" lvl="0" indent="0" algn="r" rtl="0">
-              <a:lnSpc>
-                <a:spcPct val="100000"/>
-              </a:lnSpc>
-              <a:spcBef>
-                <a:spcPts val="0"/>
-              </a:spcBef>
-              <a:spcAft>
-                <a:spcPts val="0"/>
-              </a:spcAft>
-              <a:buNone/>
-            </a:pPr>
-            <a:r>
-              <a:rPr lang="en-US" sz="900" b="0" i="0" u="none" strike="noStrike" cap="none">
-                <a:solidFill>
-                  <a:srgbClr val="13294B"/>
-                </a:solidFill>
-                <a:latin typeface="Arial"/>
-                <a:ea typeface="Arial"/>
-                <a:cs typeface="Arial"/>
-                <a:sym typeface="Arial"/>
-              </a:rPr>
-              <a:t>GRAINGER ENGINEERING</a:t>
-            </a:r>
-            <a:endParaRPr/>
-          </a:p>
-        </p:txBody>
-      </p:sp>
-      <p:sp>
-        <p:nvSpPr>
-          <p:cNvPr id="201" name="Google Shape;201;p33"/>
-          <p:cNvSpPr txBox="1"/>
-          <p:nvPr/>
-        </p:nvSpPr>
-        <p:spPr>
-          <a:xfrm>
-            <a:off x="376807" y="6524381"/>
-            <a:ext cx="7991337" cy="230792"/>
-          </a:xfrm>
-          <a:prstGeom prst="rect">
-            <a:avLst/>
-          </a:prstGeom>
-          <a:noFill/>
-          <a:ln>
-            <a:noFill/>
-          </a:ln>
-        </p:spPr>
-        <p:txBody>
-          <a:bodyPr spcFirstLastPara="1" wrap="square" lIns="91425" tIns="45700" rIns="91425" bIns="45700" anchor="t" anchorCtr="0">
-            <a:spAutoFit/>
-          </a:bodyPr>
-          <a:lstStyle/>
-          <a:p>
-            <a:pPr marL="0" marR="0" lvl="0" indent="0" algn="l" rtl="0">
-              <a:lnSpc>
-                <a:spcPct val="100000"/>
-              </a:lnSpc>
-              <a:spcBef>
-                <a:spcPts val="0"/>
-              </a:spcBef>
-              <a:spcAft>
-                <a:spcPts val="0"/>
-              </a:spcAft>
-              <a:buNone/>
-            </a:pPr>
-            <a:r>
-              <a:rPr lang="en-US" sz="900" dirty="0">
-                <a:solidFill>
-                  <a:srgbClr val="13294B"/>
-                </a:solidFill>
-              </a:rPr>
-              <a:t>SYSTEMS ENGINEERING </a:t>
-            </a:r>
-            <a:endParaRPr dirty="0"/>
-          </a:p>
-        </p:txBody>
-      </p:sp>
-      <p:grpSp>
-        <p:nvGrpSpPr>
-          <p:cNvPr id="202" name="Google Shape;202;p33"/>
-          <p:cNvGrpSpPr/>
-          <p:nvPr/>
-        </p:nvGrpSpPr>
-        <p:grpSpPr>
-          <a:xfrm>
-            <a:off x="4066674" y="6601537"/>
-            <a:ext cx="5233412" cy="70446"/>
-            <a:chOff x="4033424" y="6601537"/>
-            <a:chExt cx="5233412" cy="70446"/>
-          </a:xfrm>
-        </p:grpSpPr>
-        <p:cxnSp>
-          <p:nvCxnSpPr>
-            <p:cNvPr id="203" name="Google Shape;203;p33"/>
-            <p:cNvCxnSpPr/>
-            <p:nvPr/>
-          </p:nvCxnSpPr>
-          <p:spPr>
-            <a:xfrm rot="10800000">
-              <a:off x="4033424" y="6639606"/>
-              <a:ext cx="5164651" cy="0"/>
-            </a:xfrm>
-            <a:prstGeom prst="straightConnector1">
-              <a:avLst/>
-            </a:prstGeom>
-            <a:noFill/>
-            <a:ln w="9525" cap="flat" cmpd="sng">
-              <a:solidFill>
-                <a:srgbClr val="13294B"/>
-              </a:solidFill>
-              <a:prstDash val="solid"/>
-              <a:round/>
-              <a:headEnd type="none" w="sm" len="sm"/>
-              <a:tailEnd type="none" w="sm" len="sm"/>
-            </a:ln>
-          </p:spPr>
-        </p:cxnSp>
-        <p:sp>
-          <p:nvSpPr>
-            <p:cNvPr id="204" name="Google Shape;204;p33"/>
             <p:cNvSpPr/>
             <p:nvPr/>
           </p:nvSpPr>

</xml_diff>